<commit_message>
Tighten the deck notes and the gap list after review
- Slide 6's notes said CasparCG Connect works on 2.3.2. It aired end to
  end only on 2.5.0; on 2.3.2 AMCP answered 202 and the channel stayed
  empty because the dev-server URL it sent could not parse.
- Gap-list row 10 no longer waits on the SDI hardware item, which stays
  open for SDI exactly as A4's acceptance line does. What closes the row
  is one press of Put on air from https://noacg.studio.
- A3's status cell carries UNSEEN (box), so its row 3 has a status to
  derive from under the rule that NOT ON THE DAY is not a status.
- Slide 7's paragraph spacing moves to the paragraph's first run, so it
  lands in the first <a:pPr> pptxgenjs writes. Slide 4's guide line now
  goes through foot() instead of a copy of it.
- The generator's header dates its notes and its last build correctly.

Adds the handoff for the row.
</commit_message>
<xml_diff>
--- a/docs/presentation-2026-09-25/NoaCG-2026-09-25.pptx
+++ b/docs/presentation-2026-09-25/NoaCG-2026-09-25.pptx
@@ -971,7 +971,7 @@
               <a:t>§5, and §0 call 4 (owner, 2026-09-10) is why this slide is short. ON THE DAY AIR STOPS AT THE NOACG PLAYER IN THE CLOUD: a graphic is imported and played on our own hosted player, and seeing it work there is the proof the room gets. No OBS on a student laptop, no CasparCG box, no playout configuration of any kind. Real playout is a separate studio session later. This replaces the earlier call, which prepared four targets and chose between them on the day - if you are holding a printed deck older than 2026-09-10, the four-target slide is the one it has.
 A1 WORKS. A2 WORKS except the eyes-on half of the imported quiz over the hosted log (docs/acceptance/IMPORTED_QUIZ_HOSTED_WALK.md step 2), which the 12th is.
 IF SOMEBODY ASKS FOR THEIR OWN SYSTEM, the beats are still written in §5 and still true. Take one, do not take four, and do not put it on the clock. The cheapest is A5, an exported package played from a file with no network at all: WORKS, proven on the owner's own server, and the CasparCG package has carried an operator page since 2026-09-04.
-WHAT A REAL CASPARCG NOW SAYS (2026-09-10, docs/acceptance/owner-queue/2026-09-10-bh-a-real-casparcg-has-now-run-the-output-url.md). Both servers on this laptop have aired a published production through their screen consumer, so A4 (CG 1-20 ADD with the output URL) and A6 (Connect through the CLI agent) both work on a real 2.3.2 and a real 2.5.0. Three things from that walk are worth having if it comes up. 2.3.x is Chromium 71, measured, not the 75 or 88 the compatibility table used to infer; its flex gaps collapse, which src/assets/flexGapShim.js now puts back, while color-mix, backdrop-filter, the inset shorthand, clamp/min/max and aspect-ratio are still dropped there (docs/PLAYOUT_COMPATIBILITY.md §2). A channel restart drops the layer, and one re-issued CG ADD brings the graphic back at its LIVE state rather than the cue's authored one. And Put on air sends the output URL OF THE PAGE IT IS PRESSED ON, so pressing it on a dev server sends a URL 2.3.x cannot parse while AMCP still answers 202 and the row still says it worked.
+WHAT A REAL CASPARCG NOW SAYS (2026-09-10, docs/acceptance/owner-queue/2026-09-10-bh-a-real-casparcg-has-now-run-the-output-url.md). Both servers on this laptop have aired a published production through their screen consumer. A4 (CG 1-20 ADD with the output URL) works on a real 2.3.2 and a real 2.5.0. A6 (Put on air through the CLI agent) aired end to end on 2.5.0 only: on 2.3.2 AMCP answered 202 and the channel stayed empty, for the origin reason below, and the same production loaded by hand aired on that server a minute later. Three things from that walk are worth having if it comes up. 2.3.x is Chromium 71, measured, not the 75 or 88 the compatibility table used to infer; its flex gaps collapse, which src/assets/flexGapShim.js now puts back, while color-mix, backdrop-filter, the inset shorthand, clamp/min/max and aspect-ratio are still dropped there (docs/PLAYOUT_COMPATIBILITY.md §2). A channel restart drops the layer, and one re-issued CG ADD brings the graphic back at its LIVE state rather than the cue's authored one. And Put on air sends the output URL OF THE PAGE IT IS PRESSED ON, so pressing it on a dev server sends a URL 2.3.x cannot parse while AMCP still answers 202 and the row still says it worked.
 WHAT IS STILL UNPROVEN THERE: SDI, a Decklink card, the venue's network, and pressing Put on air from https://noacg.studio, where the browser's Local Network Access prompt needs a person. The acceptance lines in docs/STUDENT_RELEASE_ACCEPTANCE.md §1 sit unticked and the owner ticks them; none of it is on the 25th.
 A7, OGRAF. The catalog packages, the agent packages and, on 2026-09-09, an imported quiz board WITH its behaviour have all been driven in SuperFly's ograf-server (docs/OGRAF.md). Which renderer Yle runs is still not recorded: docs/acceptance/owner-queue/2026-09-10-be-which-ograf-renderer-yle-runs.md.
 A8 is not a beat. Said out loud if asked: today NoaCG packages and the renderer controls.
@@ -6952,23 +6952,23 @@
           <a:lstStyle/>
           <a:p>
             <a:pPr indent="0" marL="0">
-              <a:buNone/>
-            </a:pPr>
-            <a:r>
-              <a:rPr lang="en-US" sz="1400" b="1" dirty="0">
-                <a:solidFill>
-                  <a:srgbClr val="E8EDF2"/>
-                </a:solidFill>
-                <a:latin typeface="Arial" pitchFamily="34" charset="0"/>
-                <a:ea typeface="Arial" pitchFamily="34" charset="-122"/>
-                <a:cs typeface="Arial" pitchFamily="34" charset="-120"/>
-              </a:rPr>
-              <a:t>For the room</a:t>
-            </a:r>
-            <a:pPr indent="0" marL="0">
               <a:spcAft>
                 <a:spcPts val="500"/>
               </a:spcAft>
+              <a:buNone/>
+            </a:pPr>
+            <a:r>
+              <a:rPr lang="en-US" sz="1400" b="1" dirty="0">
+                <a:solidFill>
+                  <a:srgbClr val="E8EDF2"/>
+                </a:solidFill>
+                <a:latin typeface="Arial" pitchFamily="34" charset="0"/>
+                <a:ea typeface="Arial" pitchFamily="34" charset="-122"/>
+                <a:cs typeface="Arial" pitchFamily="34" charset="-120"/>
+              </a:rPr>
+              <a:t>For the room</a:t>
+            </a:r>
+            <a:pPr indent="0" marL="0">
               <a:buNone/>
             </a:pPr>
             <a:r>

</xml_diff>

<commit_message>
Take the deck rebuild off this branch
Row CA's own rebuild of the same deck files is queued as pull request
250. Two independent rebuilds of one binary cannot merge, so this branch
keeps none of it; the corrections this branch found in slides 2, 3 and 5
are applied on top of CA's deck once it has landed, or recorded for a
follow-up.
</commit_message>
<xml_diff>
--- a/docs/presentation-2026-09-25/NoaCG-2026-09-25.pptx
+++ b/docs/presentation-2026-09-25/NoaCG-2026-09-25.pptx
@@ -508,11 +508,11 @@
           <a:p>
             <a:r>
               <a:rPr lang="en-US" dirty="0"/>
-              <a:t>BEFORE THE ROOM, NOT IN IT. B0, the network: the 2026-08-20 Yle demo failed on Yle's network, and the diag screenshot from that network (https://noacg.studio/app?diag=1) is the owner's own, off the ledger since 2026-09-10 - "I will take care of the Yle network screenshot when I get there, you do not have to remind me" - so nothing here reminds him again. If it has not happened, the phone hotspot is the plan and you say so in the room. That fallback carries more weight since §0 call 4: with air ending at our own hosted player, a network that blocks the app takes the whole session rather than one beat. This deck opens from a file and needs no network.
+              <a:t>BEFORE THE ROOM, NOT IN IT. B0, the network: the 2026-08-20 Yle demo failed on Yle's network, and the diag screenshot from that network (https://noacg.studio/app?diag=1) is still an open owner item, docs/acceptance/owner-queue/2026-09-09-g-yle-network-diag-screenshot.md. If it has not arrived, the phone hotspot is the plan and you say so in the room. This deck opens from a file and needs no network.
 B1: the morning of, check https://noacg.studio/version.json against the tip of main.
-THE CLOCK, re-cut 2026-09-10 for calls 4 and 6: 10 opening, 20 road 1, 25 drawing in small groups, 25 road 2, 10 on air and the close. A beat that runs long is cut at the next beat's boundary, never stretched.
-WHO DRIVES. They do, on their own laptops, for everything the day now contains. We drive one agent on the screen. Nobody drives a playout box: §0 call 4 took OBS, CasparCG and the OGraf renderer off the day, and they are a studio session later.
-Source: docs/DEMO_2026-09-25.md §0 (the six calls, the re-cut timing), §1 (B0, B1).</a:t>
+THE CLOCK. 10 opening, 30 road 1, 25 road 2, 20 on air, 5 close. A beat that runs long is cut at the next beat's boundary, never stretched.
+WHO DRIVES. They do, on their own laptops. We drive the CasparCG box, the OGraf renderer and one agent on the screen.
+Source: docs/DEMO_2026-09-25.md §0 (the five calls, timing), §1 (B0, B1).</a:t>
             </a:r>
             <a:endParaRPr lang="en-US" dirty="0"/>
           </a:p>
@@ -601,7 +601,7 @@
             <a:r>
               <a:rPr lang="en-US" dirty="0"/>
               <a:t>O1. Every sentence on this slide has a row in docs/PROMISE_AUDIT.md, cited by its promise text: "Free and open source, AGPL-3.0, no paid edition"; "No lock-in: real HTML/CSS/JS, self-contained packages, runs from a local file with no internet" (WORKS WITH A STATED LIMITATION: the single-file targets and the SPX folder run from a file; an OGraf or LiveOS package is ES modules and needs an http server, which is why the slide says single-file); "Exports to SPX Graphics, CasparCG, OBS and vMix, H2R, LiveOS, OGraf"; "No account to create, edit and export"; "A production ... one persistent output URL" (the free account).
-IF ASKED. The exported package has run on the owner's own CasparCG since 2026-08-05 (docs/STUDENT_RELEASE_ACCEPTANCE.md §2). Since 2026-09-10 the output URL and CasparCG Connect have both aired on a real 2.3.2 and a real 2.5.0, on a screen consumer (§5 A4 and A6). SDI, a Decklink card and pressing Put on air from noacg.studio are still unproven.
+IF ASKED. CasparCG Connect through the CLI agent has not been run against real hardware; the exported package has (docs/STUDENT_RELEASE_ACCEPTANCE.md §2).
 Source: docs/DEMO_2026-09-25.md §2 O1; docs/PROMISE_AUDIT.md.</a:t>
             </a:r>
             <a:endParaRPr lang="en-US" dirty="0"/>
@@ -692,8 +692,7 @@
               <a:rPr lang="en-US" dirty="0"/>
               <a:t>O2. This is the deck the script asked for: one picture plus the beat headings. Say the shape out loud now so the room knows why on-air comes last: an imported SVG and an agent-made graphic both become a library record, both go into a production, and both air through one output URL (§0, call 2).
 ORDER. Road 1 goes first because the whole room can do it with no terminal, no subscription and no account (§0, call 3).
-THE RIGHT-HAND COLUMN IS LATER, NOT TODAY. On the day the URL plays on our own hosted player and nowhere else (§0 call 4, owner 2026-09-10). OBS, CasparCG and OGraf are drawn dim because they are where the same URL or package goes in a studio session afterwards. Say that once, here, so nobody spends the session waiting for the box.
-Source: docs/DEMO_2026-09-25.md §0 calls 2, 3 and 4, §2 O2.</a:t>
+Source: docs/DEMO_2026-09-25.md §0 calls 2 and 3, §2 O2.</a:t>
             </a:r>
             <a:endParaRPr lang="en-US" dirty="0"/>
           </a:p>
@@ -781,15 +780,12 @@
           <a:p>
             <a:r>
               <a:rPr lang="en-US" dirty="0"/>
-              <a:t>§3, R1.1 to R1.7. Status on 2026-09-10: WORKS on the shipped samples for the six road beats, with one exception. R1.4, behaviour on artwork nobody at NoaCG drew, is pinned by e2e/import-svg-behaviour.spec.ts, but you have not looked at your OWN quiz board since the three text-box fixes (docs/TEXT_BOX_BINDING.md). The 12th is that walk.
-TWO PIECES OF DRAWING, AND THEY MUST NOT BE CONFUSED (§0 call 6, owner 2026-09-10). What the room imports and plays inside the session is ONE SIMPLE GRAPHIC, a lower third, because the session is proving the road works end to end. The real artwork is the take-home: small groups draw a lower-third quiz template and a scoreboard in Illustrator, start them here, finish them in their own time and send them in. The 25 minutes on the panel are the re-cut clock in §0, and they come out of what road 1 and on air used to have.
-R1.7 HAS ONE HOLE AND IT IS NOT IN THE PRODUCT. How a finished file comes BACK - where a group sends it, in what format, and what we do with it - is not written anywhere yet. §7 row 17; one paragraph in the student one-page index (G2) closes it. If the room asks and it is still open, take an address and say we will write back rather than inventing a route at the front.
-WHY THE SAMPLES ARE THE ROAD IN THE ROOM. docs/svg-samples/quiz-board.svg and scorebug.svg are the two files e2e/import-svg-behaviour.spec.ts drives all the way through behaviour, so a group that follows their layer naming gets a working quiz and a working scoreboard rather than a static picture. R1.4 is what their own file will do when it comes back.
+              <a:t>§3, R1.1 to R1.6. Status on 2026-09-09: WORKS on the shipped samples for all six beats, with one exception. R1.4, behaviour on artwork nobody at NoaCG drew, is pinned by e2e/import-svg-behaviour.spec.ts, but you have not looked at your OWN quiz board since the three text-box fixes (docs/TEXT_BOX_BINDING.md). The 12th is that walk.
 R1.3 ON THEIR OWN FILE. The growth default is measured off the geometry and for some exporter shapes it disagrees with what the designer meant (docs/backlog/svg-growth-default-across-exporters.md). That is why the dropdown sentence is said out loud rather than waited for.
 THE ROAD, IN SCREENS. Start, Design, Fields, Animation, Finish (src/components/wizard/CreationWizard.tsx, STEP_TITLES_SVG). "Create project" sits in the footer beside Design, Fields and Animation - not on Start, not on Finish - and it does NOT save: it builds with defaults for everything not yet reached and hands you to the code editor (create() calls applyDraftProject() with no arguments). The two doors the default studio shows on Finish, the production one and Export, both save. DO NOT name Create project in the room: send people to Finish and to a door by name. docs/backlog/create-project-is-a-door-that-saves-nothing.md is the open question about whether that button should be renamed or should save.
 R1.5. A Yle designer's licensed face takes the upload road, in the Typefaces row on the FIELDS step - two screens before the end. The Google door is offered only where Google has the family.
 NOT A BEAT. The live-vote encore needs a fixture brought by hand and has two open backlog items; only if the room is ahead of the clock.
-Source: docs/DEMO_2026-09-25.md §0 call 6, §3 R1.1 to R1.7, §7 row 17; the guide is docs.html #first-graphic, landed 2026-09-09.</a:t>
+Source: docs/DEMO_2026-09-25.md §3; the guide is docs.html #first-graphic, landed 2026-09-09.</a:t>
             </a:r>
             <a:endParaRPr lang="en-US" dirty="0"/>
           </a:p>
@@ -879,10 +875,9 @@
               <a:rPr lang="en-US" dirty="0"/>
               <a:t>§4. R2.1 is for everyone, subscription or not. R2.3: you drive one agent on the screen; the evidence is the 2026-08-22 round, 25 of 25 cells validator-clean and every one airable in your own blind read (benchmarks/agent/rounds/2026-08-22/VERDICT.md).
 THE NUMBER. docs/AGENT_CLI.md, "Time to air, measured": one walk, one machine, 2026-09-09, against a dev server on the branch's own build (not 0.3.0 from npm), from an empty folder. 24.8 s is doctor + types + scaffold + validate + inspect + screenshot + pack. Setup once per machine is another 8.7 s.
-R2.5: TWO NUMBERS, AND THE LAST HOP IS UNTIMED. 24.8 s is the seven local verbs, a local build against a dev server on 2026-09-09. 9.3 s is save into the live library, the published 0.3.0 against noacg.studio on 2026-09-10. About thirty-five seconds of tool time from an empty folder to a graphic in your library, said as the two numbers. The hop from the library to a production's output URL has not been timed (§7 row 15). Do not round up to a minute and do not say "minutes to air".
-R2.4, THE TWO DEFECTS THE LIVE SAVE FOUND (§7 row 14). The link save prints lands on Home, not on the graphic; the graphic is in Recent graphics 5 s later, so say "it is in your library" and open it from there. And login stores the key and then hangs instead of exiting: warn the room that the terminal goes quiet after they press Allow, and that Ctrl-C is safe. The two comments in the code panel say both.
-ON THIS LAPTOP, BEFORE THE DAY (§7 row 16). The global @noacg/cli here is 0.2.0 and the MCP server prefers it over npx, so R2.3 would run a year of fixes behind with nothing on screen saying so. One command: npm i -g @noacg/cli@latest.
-Source: docs/DEMO_2026-09-25.md §4 R2.1 to R2.5, §7 rows 14, 15 and 16; docs/AGENT_CLI.md "Time to air, measured".</a:t>
+R2.5: THE CLOUD LEG IS UNTIMED. The measurement stopped at the package's own fallback player. The cloud save and the studio's output URL were not walked: save refused against the dev server (the CLI's key store is per origin) and writing into the live library from an unattended session was not done. The script carries that leg as §7 row 8, the live save with a stopwatch on it. Do not say "minutes to air" as a measured claim; the slide's wording is the honest one.
+UNSEEN SINCE 2026-08-23. R2.1 against noacg.studio and R2.4 the live save (§7 row 8), and B5 the install lines on a fresh machine, last executed 2026-08-22 for Claude Code and 2026-08-27 for Codex, with the Codex side of the noacg-mcp split not re-verified (§7 row 6). Both are cheap to close before the day.
+Source: docs/DEMO_2026-09-25.md §4, §7 rows 6, 8; docs/AGENT_CLI.md "Time to air, measured".</a:t>
             </a:r>
             <a:endParaRPr lang="en-US" dirty="0"/>
           </a:p>
@@ -970,15 +965,14 @@
           <a:p>
             <a:r>
               <a:rPr lang="en-US" dirty="0"/>
-              <a:t>§5, and §0 call 4 (owner, 2026-09-10) is why this slide is short. ON THE DAY AIR STOPS AT THE NOACG PLAYER IN THE CLOUD: a graphic is imported and played on our own hosted player, and seeing it work there is the proof the room gets. No OBS on a student laptop, no CasparCG box, no playout configuration of any kind. Real playout is a separate studio session later. This replaces the earlier call, which prepared four targets and chose between them on the day - if you are holding a printed deck older than 2026-09-10, the four-target slide is the one it has.
-A1 WORKS. A2 WORKS except the eyes-on half of the imported quiz over the hosted log (docs/acceptance/IMPORTED_QUIZ_HOSTED_WALK.md step 2), which the 12th is.
-IF SOMEBODY ASKS FOR THEIR OWN SYSTEM, the beats are still written in §5 and still true. Take one, do not take four, and do not put it on the clock. The cheapest is A5, an exported package played from a file with no network at all: WORKS, proven on the owner's own server, and the CasparCG package has carried an operator page since 2026-09-04.
-WHAT A REAL CASPARCG NOW SAYS (2026-09-10, docs/acceptance/owner-queue/2026-09-10-bh-a-real-casparcg-has-now-run-the-output-url.md). Both servers on this laptop have aired a published production through their screen consumer, so A4 (CG 1-20 ADD with the output URL) and A6 (Connect through the CLI agent) both work on a real 2.3.2 and a real 2.5.0. Three things from that walk are worth having if it comes up. 2.3.x is Chromium 71, measured, not the 75 or 88 the compatibility table used to infer; its flex gaps collapse, which src/assets/flexGapShim.js now puts back, while color-mix, backdrop-filter, the inset shorthand, clamp/min/max and aspect-ratio are still dropped there (docs/PLAYOUT_COMPATIBILITY.md §2). A channel restart drops the layer, and one re-issued CG ADD brings the graphic back at its LIVE state rather than the cue's authored one. And Put on air sends the output URL OF THE PAGE IT IS PRESSED ON, so pressing it on a dev server sends a URL 2.3.x cannot parse while AMCP still answers 202 and the row still says it worked.
-WHAT IS STILL UNPROVEN THERE: SDI, a Decklink card, the venue's network, and pressing Put on air from https://noacg.studio, where the browser's Local Network Access prompt needs a person. The acceptance lines in docs/STUDENT_RELEASE_ACCEPTANCE.md §1 sit unticked and the owner ticks them; none of it is on the 25th.
-A7, OGRAF. The catalog packages, the agent packages and, on 2026-09-09, an imported quiz board WITH its behaviour have all been driven in SuperFly's ograf-server (docs/OGRAF.md). Which renderer Yle runs is still not recorded: docs/acceptance/owner-queue/2026-09-10-be-which-ograf-renderer-yle-runs.md.
-A8 is not a beat. Said out loud if asked: today NoaCG packages and the renderer controls.
+              <a:t>§5. A1 WORKS. A2 WORKS except the eyes-on half of the imported quiz over the hosted log (docs/acceptance/IMPORTED_QUIZ_HOSTED_WALK.md step 2), which the 12th is. Status of the four targets on 2026-09-09:
+OBS (A3): UNSEEN (box). The route is written and the output page's recovery is pinned, but no written tick exists for the OBS half because §1 of docs/STUDENT_RELEASE_ACCEPTANCE.md has no OBS line. You have done it; on the 12th you write the line and tick it.
+CASPARCG WITH THE URL (A4): UNSEEN (box). The output page is compiled down to what 2.3.x runs; unseen on a real box until the 12th ticks the §8.7 line. If it is red there, the file export is the fallback in the same room.
+CASPARCG OR SPX WITH A FILE (A5): WORKS, proven on your own server; the CasparCG package has carried an operator page since 2026-09-04.
+OGRAF (A7): catalog and agent packages were driven in SuperFly's ograf-server on 2026-08-18 and 2026-08-22 (docs/OGRAF.md). An imported-SVG graphic WITH behaviour has not been driven in an external renderer (§7 row 7), and which renderer Yle runs is asked in the same owner message as the network screenshot.
+NOT ON THE SLIDE. A6, CasparCG Connect through the CLI agent: show it only if the 12th proves it on hardware; A4 does the same job by hand. A8, NoaCG driving a production on an OGraf renderer with the renderer in control: not a beat; if asked, today NoaCG packages and the renderer controls.
 B2. Email confirmation is off, so a sign-up works at once. If the dialog still says "Check your email to confirm your account", tell the room to ignore that line (docs/backlog/sign-up-says-check-your-email-with-confirmations-off.md).
-Source: docs/DEMO_2026-09-25.md §0 call 4, §5, §7 rows 3 and 10. Row 2, the output URL on a real CasparCG, closed on 2026-09-10 with the walk above.</a:t>
+Source: docs/DEMO_2026-09-25.md §5, §7 rows 2, 3, 7, 10, 11; docs/STUDENT_RELEASE_ACCEPTANCE.md §1, §2.</a:t>
             </a:r>
             <a:endParaRPr lang="en-US" dirty="0"/>
           </a:p>
@@ -1067,9 +1061,8 @@
             <a:r>
               <a:rPr lang="en-US" dirty="0"/>
               <a:t>G1. The end-to-end SVG page is /docs#first-graphic, landed 2026-09-09; the CLI page was end to end already. Each section is pinned by e2e/docs.spec.ts.
-G2 IS TWO PAGES, NOT ONE (owner, 2026-09-10, §0 call 5), and it is still a GAP: §7 row 12, written in the week of the 22nd. The student page is the one that is handed out and then shared as a file afterwards, and the take-home brief from R1.7 lives on it - which is also where §7 row 17, how a finished file comes back, gets its one paragraph. The owner page is your running order: the same beats, who drives each, and the clock from §0. Until both exist, print this deck's notes pages, one slide per page with the notes under it.
-THE ANCHORS ON THIS SLIDE ARE THE GUIDE, NOT THE DAY. #obs and #casparcg stay on the list because the guide covers them and people take it home; the session itself stops at our own player (§0 call 4), which is what slide 6 says.
-Source: docs/DEMO_2026-09-25.md §0 calls 4 and 5, §6 G1 and G2, §7 rows 12 and 17.</a:t>
+G2, THE PRINTED ONE-PAGE INDEX, DOES NOT EXIST and is not on this slide (§7 row 12). If the laptop dies, print this deck's notes pages: one slide per page with these notes under it.
+Source: docs/DEMO_2026-09-25.md §6, §7 row 12.</a:t>
             </a:r>
             <a:endParaRPr lang="en-US" dirty="0"/>
           </a:p>
@@ -1749,7 +1742,7 @@
         <p:spPr>
           <a:xfrm>
             <a:off x="640080" y="4434840"/>
-            <a:ext cx="8412480" cy="1005840"/>
+            <a:ext cx="8412480" cy="914400"/>
           </a:xfrm>
           <a:prstGeom prst="rect">
             <a:avLst/>
@@ -1776,7 +1769,7 @@
                 <a:ea typeface="Arial" pitchFamily="34" charset="-122"/>
                 <a:cs typeface="Arial" pitchFamily="34" charset="-120"/>
               </a:rPr>
-              <a:t>Draw one, or ask your coding agent for one. Put it on air from a browser, on our player. Then take it to whatever you already run.</a:t>
+              <a:t>Draw one, or ask your coding agent for one. Put it on air from a browser. Then run it on whatever you already have in the room.</a:t>
             </a:r>
             <a:endParaRPr lang="en-US" sz="2200" dirty="0"/>
           </a:p>
@@ -1815,7 +1808,7 @@
                 <a:ea typeface="Arial" pitchFamily="34" charset="-122"/>
                 <a:cs typeface="Arial" pitchFamily="34" charset="-120"/>
               </a:rPr>
-              <a:t>Ninety minutes. You drive; we drive only the agent on the screen.</a:t>
+              <a:t>Ninety minutes. You drive; we drive only what needs a playout box or an agent subscription.</a:t>
             </a:r>
             <a:endParaRPr lang="en-US" sz="1400" dirty="0"/>
           </a:p>
@@ -2798,7 +2791,7 @@
                 <a:ea typeface="Consolas" pitchFamily="34" charset="-122"/>
                 <a:cs typeface="Consolas" pitchFamily="34" charset="-120"/>
               </a:rPr>
-              <a:t>YOUR SYSTEMS, LATER</a:t>
+              <a:t>THE ROOM'S SYSTEMS</a:t>
             </a:r>
             <a:endParaRPr lang="en-US" sz="1100" dirty="0"/>
           </a:p>
@@ -3381,7 +3374,7 @@
                 <a:ea typeface="Arial" pitchFamily="34" charset="-122"/>
                 <a:cs typeface="Arial" pitchFamily="34" charset="-120"/>
               </a:rPr>
-              <a:t>Plays on our player.</a:t>
+              <a:t>The output, live.</a:t>
             </a:r>
             <a:endParaRPr lang="en-US" sz="1250" dirty="0"/>
           </a:p>
@@ -3532,7 +3525,7 @@
             <a:r>
               <a:rPr lang="en-US" sz="1400" b="1" dirty="0">
                 <a:solidFill>
-                  <a:srgbClr val="8B98A8"/>
+                  <a:srgbClr val="E8EDF2"/>
                 </a:solidFill>
                 <a:latin typeface="Arial" pitchFamily="34" charset="0"/>
                 <a:ea typeface="Arial" pitchFamily="34" charset="-122"/>
@@ -3593,7 +3586,7 @@
             <a:r>
               <a:rPr lang="en-US" sz="1400" b="1" dirty="0">
                 <a:solidFill>
-                  <a:srgbClr val="8B98A8"/>
+                  <a:srgbClr val="E8EDF2"/>
                 </a:solidFill>
                 <a:latin typeface="Arial" pitchFamily="34" charset="0"/>
                 <a:ea typeface="Arial" pitchFamily="34" charset="-122"/>
@@ -3654,7 +3647,7 @@
             <a:r>
               <a:rPr lang="en-US" sz="1400" b="1" dirty="0">
                 <a:solidFill>
-                  <a:srgbClr val="8B98A8"/>
+                  <a:srgbClr val="E8EDF2"/>
                 </a:solidFill>
                 <a:latin typeface="Arial" pitchFamily="34" charset="0"/>
                 <a:ea typeface="Arial" pitchFamily="34" charset="-122"/>
@@ -3683,7 +3676,7 @@
           <a:noFill/>
           <a:ln w="19050">
             <a:solidFill>
-              <a:srgbClr val="8B98A8"/>
+              <a:srgbClr val="F6A623"/>
             </a:solidFill>
             <a:prstDash val="solid"/>
             <a:tailEnd type="triangle"/>
@@ -3707,7 +3700,7 @@
           <a:noFill/>
           <a:ln w="19050">
             <a:solidFill>
-              <a:srgbClr val="8B98A8"/>
+              <a:srgbClr val="F6A623"/>
             </a:solidFill>
             <a:prstDash val="solid"/>
             <a:tailEnd type="triangle"/>
@@ -3731,7 +3724,7 @@
           <a:noFill/>
           <a:ln w="19050">
             <a:solidFill>
-              <a:srgbClr val="8B98A8"/>
+              <a:srgbClr val="F6A623"/>
             </a:solidFill>
             <a:prstDash val="solid"/>
             <a:tailEnd type="triangle"/>
@@ -3923,7 +3916,7 @@
                 <a:ea typeface="Consolas" pitchFamily="34" charset="-122"/>
                 <a:cs typeface="Consolas" pitchFamily="34" charset="-120"/>
               </a:rPr>
-              <a:t>ROAD 1  ·  20 MIN  ·  YOU DRIVE</a:t>
+              <a:t>ROAD 1  ·  30 MIN  ·  YOU DRIVE</a:t>
             </a:r>
             <a:endParaRPr lang="en-US" sz="1200" dirty="0"/>
           </a:p>
@@ -4043,7 +4036,7 @@
                 <a:ea typeface="Arial" pitchFamily="34" charset="-122"/>
                 <a:cs typeface="Arial" pitchFamily="34" charset="-120"/>
               </a:rPr>
-              <a:t>Take the lower-third sample, or a file you drew to the five rules.</a:t>
+              <a:t>Draw it to the five rules, or take a sample.</a:t>
             </a:r>
             <a:endParaRPr lang="en-US" sz="1900" dirty="0"/>
           </a:p>
@@ -4074,7 +4067,7 @@
         </p:nvSpPr>
         <p:spPr>
           <a:xfrm>
-            <a:off x="640080" y="2642616"/>
+            <a:off x="640080" y="2679192"/>
             <a:ext cx="457200" cy="274320"/>
           </a:xfrm>
           <a:prstGeom prst="rect">
@@ -4113,7 +4106,7 @@
         </p:nvSpPr>
         <p:spPr>
           <a:xfrm>
-            <a:off x="1143000" y="2596896"/>
+            <a:off x="1143000" y="2633472"/>
             <a:ext cx="5897880" cy="868680"/>
           </a:xfrm>
           <a:prstGeom prst="rect">
@@ -4172,7 +4165,7 @@
         </p:nvSpPr>
         <p:spPr>
           <a:xfrm>
-            <a:off x="640080" y="3502152"/>
+            <a:off x="640080" y="3575304"/>
             <a:ext cx="457200" cy="274320"/>
           </a:xfrm>
           <a:prstGeom prst="rect">
@@ -4211,7 +4204,7 @@
         </p:nvSpPr>
         <p:spPr>
           <a:xfrm>
-            <a:off x="1143000" y="3456432"/>
+            <a:off x="1143000" y="3529584"/>
             <a:ext cx="5897880" cy="868680"/>
           </a:xfrm>
           <a:prstGeom prst="rect">
@@ -4270,7 +4263,7 @@
         </p:nvSpPr>
         <p:spPr>
           <a:xfrm>
-            <a:off x="640080" y="4361688"/>
+            <a:off x="640080" y="4471416"/>
             <a:ext cx="457200" cy="274320"/>
           </a:xfrm>
           <a:prstGeom prst="rect">
@@ -4309,7 +4302,7 @@
         </p:nvSpPr>
         <p:spPr>
           <a:xfrm>
-            <a:off x="1143000" y="4315968"/>
+            <a:off x="1143000" y="4425696"/>
             <a:ext cx="5897880" cy="868680"/>
           </a:xfrm>
           <a:prstGeom prst="rect">
@@ -4368,7 +4361,7 @@
         </p:nvSpPr>
         <p:spPr>
           <a:xfrm>
-            <a:off x="640080" y="5221224"/>
+            <a:off x="640080" y="5367528"/>
             <a:ext cx="457200" cy="274320"/>
           </a:xfrm>
           <a:prstGeom prst="rect">
@@ -4407,7 +4400,7 @@
         </p:nvSpPr>
         <p:spPr>
           <a:xfrm>
-            <a:off x="1143000" y="5175504"/>
+            <a:off x="1143000" y="5321808"/>
             <a:ext cx="5897880" cy="868680"/>
           </a:xfrm>
           <a:prstGeom prst="rect">
@@ -4467,11 +4460,11 @@
         <p:spPr>
           <a:xfrm>
             <a:off x="7406640" y="1737360"/>
-            <a:ext cx="4144975" cy="1965960"/>
+            <a:ext cx="4144975" cy="1783080"/>
           </a:xfrm>
           <a:prstGeom prst="roundRect">
             <a:avLst>
-              <a:gd name="adj" fmla="val 4651"/>
+              <a:gd name="adj" fmla="val 5128"/>
             </a:avLst>
           </a:prstGeom>
           <a:solidFill>
@@ -4488,8 +4481,8 @@
         </p:nvSpPr>
         <p:spPr>
           <a:xfrm>
-            <a:off x="7607808" y="1938528"/>
-            <a:ext cx="3742639" cy="237744"/>
+            <a:off x="7680960" y="2011680"/>
+            <a:ext cx="3596335" cy="237744"/>
           </a:xfrm>
           <a:prstGeom prst="rect">
             <a:avLst/>
@@ -4513,7 +4506,7 @@
                 <a:ea typeface="Consolas" pitchFamily="34" charset="-122"/>
                 <a:cs typeface="Consolas" pitchFamily="34" charset="-120"/>
               </a:rPr>
-              <a:t>THE TAKE-HOME  ·  25 MIN IN GROUPS</a:t>
+              <a:t>SAY IT BEFORE THEY ASK</a:t>
             </a:r>
             <a:endParaRPr lang="en-US" sz="1100" dirty="0"/>
           </a:p>
@@ -4527,8 +4520,8 @@
         </p:nvSpPr>
         <p:spPr>
           <a:xfrm>
-            <a:off x="7607808" y="2231136"/>
-            <a:ext cx="3742639" cy="1051560"/>
+            <a:off x="7680960" y="2331720"/>
+            <a:ext cx="3596335" cy="1097280"/>
           </a:xfrm>
           <a:prstGeom prst="rect">
             <a:avLst/>
@@ -4547,7 +4540,7 @@
               <a:buNone/>
             </a:pPr>
             <a:r>
-              <a:rPr lang="en-US" sz="1400" dirty="0">
+              <a:rPr lang="en-US" sz="1600" dirty="0">
                 <a:solidFill>
                   <a:srgbClr val="C6CCD6"/>
                 </a:solidFill>
@@ -4555,7 +4548,7 @@
                 <a:ea typeface="Arial" pitchFamily="34" charset="-122"/>
                 <a:cs typeface="Arial" pitchFamily="34" charset="-120"/>
               </a:rPr>
-              <a:t>Small groups, in Illustrator: </a:t>
+              <a:t>If a long name does not grow the way you meant, the answer is one dropdown on the Fields step: </a:t>
             </a:r>
             <a:pPr indent="0" marL="0">
               <a:lnSpc>
@@ -4564,15 +4557,15 @@
               <a:buNone/>
             </a:pPr>
             <a:r>
-              <a:rPr lang="en-US" sz="1400" b="1" dirty="0">
-                <a:solidFill>
-                  <a:srgbClr val="E8EDF2"/>
+              <a:rPr lang="en-US" sz="1600" b="1" dirty="0">
+                <a:solidFill>
+                  <a:srgbClr val="C6CCD6"/>
                 </a:solidFill>
                 <a:latin typeface="Arial" pitchFamily="34" charset="0"/>
                 <a:ea typeface="Arial" pitchFamily="34" charset="-122"/>
                 <a:cs typeface="Arial" pitchFamily="34" charset="-120"/>
               </a:rPr>
-              <a:t>a lower-third quiz template</a:t>
+              <a:t>When the text is too long</a:t>
             </a:r>
             <a:pPr indent="0" marL="0">
               <a:lnSpc>
@@ -4581,7 +4574,7 @@
               <a:buNone/>
             </a:pPr>
             <a:r>
-              <a:rPr lang="en-US" sz="1400" dirty="0">
+              <a:rPr lang="en-US" sz="1600" dirty="0">
                 <a:solidFill>
                   <a:srgbClr val="C6CCD6"/>
                 </a:solidFill>
@@ -4589,8 +4582,55 @@
                 <a:ea typeface="Arial" pitchFamily="34" charset="-122"/>
                 <a:cs typeface="Arial" pitchFamily="34" charset="-120"/>
               </a:rPr>
-              <a:t> and </a:t>
-            </a:r>
+              <a:t>.</a:t>
+            </a:r>
+            <a:endParaRPr lang="en-US" sz="1600" dirty="0"/>
+          </a:p>
+        </p:txBody>
+      </p:sp>
+      <p:sp>
+        <p:nvSpPr>
+          <p:cNvPr id="18" name="Shape 16"/>
+          <p:cNvSpPr/>
+          <p:nvPr/>
+        </p:nvSpPr>
+        <p:spPr>
+          <a:xfrm>
+            <a:off x="7406640" y="3657600"/>
+            <a:ext cx="4144975" cy="1188720"/>
+          </a:xfrm>
+          <a:prstGeom prst="roundRect">
+            <a:avLst>
+              <a:gd name="adj" fmla="val 7692"/>
+            </a:avLst>
+          </a:prstGeom>
+          <a:solidFill>
+            <a:srgbClr val="141922"/>
+          </a:solidFill>
+          <a:ln/>
+        </p:spPr>
+      </p:sp>
+      <p:sp>
+        <p:nvSpPr>
+          <p:cNvPr id="19" name="Text 17"/>
+          <p:cNvSpPr txBox="1"/>
+          <p:nvPr/>
+        </p:nvSpPr>
+        <p:spPr>
+          <a:xfrm>
+            <a:off x="7680960" y="3931920"/>
+            <a:ext cx="3596335" cy="822960"/>
+          </a:xfrm>
+          <a:prstGeom prst="rect">
+            <a:avLst/>
+          </a:prstGeom>
+          <a:noFill/>
+          <a:ln/>
+        </p:spPr>
+        <p:txBody>
+          <a:bodyPr wrap="square" lIns="0" tIns="0" rIns="0" bIns="0" rtlCol="0" anchor="t"/>
+          <a:lstStyle/>
+          <a:p>
             <a:pPr indent="0" marL="0">
               <a:lnSpc>
                 <a:spcPct val="115000"/>
@@ -4598,15 +4638,15 @@
               <a:buNone/>
             </a:pPr>
             <a:r>
-              <a:rPr lang="en-US" sz="1400" b="1" dirty="0">
-                <a:solidFill>
-                  <a:srgbClr val="E8EDF2"/>
+              <a:rPr lang="en-US" sz="1600" dirty="0">
+                <a:solidFill>
+                  <a:srgbClr val="C6CCD6"/>
                 </a:solidFill>
                 <a:latin typeface="Arial" pitchFamily="34" charset="0"/>
                 <a:ea typeface="Arial" pitchFamily="34" charset="-122"/>
                 <a:cs typeface="Arial" pitchFamily="34" charset="-120"/>
               </a:rPr>
-              <a:t>a scoreboard</a:t>
+              <a:t>A typeface Google does not have, or a licensed one, takes the </a:t>
             </a:r>
             <a:pPr indent="0" marL="0">
               <a:lnSpc>
@@ -4615,7 +4655,7 @@
               <a:buNone/>
             </a:pPr>
             <a:r>
-              <a:rPr lang="en-US" sz="1400" dirty="0">
+              <a:rPr lang="en-US" sz="1600" b="1" dirty="0">
                 <a:solidFill>
                   <a:srgbClr val="C6CCD6"/>
                 </a:solidFill>
@@ -4623,99 +4663,116 @@
                 <a:ea typeface="Arial" pitchFamily="34" charset="-122"/>
                 <a:cs typeface="Arial" pitchFamily="34" charset="-120"/>
               </a:rPr>
-              <a:t>. Started here, finished in your own time, sent in.</a:t>
-            </a:r>
-            <a:endParaRPr lang="en-US" sz="1400" dirty="0"/>
-          </a:p>
-        </p:txBody>
-      </p:sp>
-      <p:sp>
-        <p:nvSpPr>
-          <p:cNvPr id="18" name="Text 16"/>
-          <p:cNvSpPr txBox="1"/>
-          <p:nvPr/>
-        </p:nvSpPr>
-        <p:spPr>
-          <a:xfrm>
-            <a:off x="7607808" y="3383280"/>
-            <a:ext cx="3742639" cy="228600"/>
-          </a:xfrm>
-          <a:prstGeom prst="rect">
-            <a:avLst/>
-          </a:prstGeom>
-          <a:noFill/>
-          <a:ln/>
-        </p:spPr>
-        <p:txBody>
-          <a:bodyPr wrap="square" lIns="0" tIns="0" rIns="0" bIns="0" rtlCol="0" anchor="t"/>
-          <a:lstStyle/>
-          <a:p>
-            <a:pPr indent="0" marL="0">
-              <a:buNone/>
-            </a:pPr>
-            <a:r>
-              <a:rPr lang="en-US" sz="1200" dirty="0">
-                <a:solidFill>
-                  <a:srgbClr val="8B98A8"/>
+              <a:t>upload</a:t>
+            </a:r>
+            <a:pPr indent="0" marL="0">
+              <a:lnSpc>
+                <a:spcPct val="115000"/>
+              </a:lnSpc>
+              <a:buNone/>
+            </a:pPr>
+            <a:r>
+              <a:rPr lang="en-US" sz="1600" dirty="0">
+                <a:solidFill>
+                  <a:srgbClr val="C6CCD6"/>
+                </a:solidFill>
+                <a:latin typeface="Arial" pitchFamily="34" charset="0"/>
+                <a:ea typeface="Arial" pitchFamily="34" charset="-122"/>
+                <a:cs typeface="Arial" pitchFamily="34" charset="-120"/>
+              </a:rPr>
+              <a:t> road in the Typefaces row, on the Fields step.</a:t>
+            </a:r>
+            <a:endParaRPr lang="en-US" sz="1600" dirty="0"/>
+          </a:p>
+        </p:txBody>
+      </p:sp>
+      <p:sp>
+        <p:nvSpPr>
+          <p:cNvPr id="20" name="Shape 18"/>
+          <p:cNvSpPr/>
+          <p:nvPr/>
+        </p:nvSpPr>
+        <p:spPr>
+          <a:xfrm>
+            <a:off x="7406640" y="4983480"/>
+            <a:ext cx="4144975" cy="960120"/>
+          </a:xfrm>
+          <a:prstGeom prst="roundRect">
+            <a:avLst>
+              <a:gd name="adj" fmla="val 9524"/>
+            </a:avLst>
+          </a:prstGeom>
+          <a:solidFill>
+            <a:srgbClr val="141922"/>
+          </a:solidFill>
+          <a:ln/>
+        </p:spPr>
+      </p:sp>
+      <p:sp>
+        <p:nvSpPr>
+          <p:cNvPr id="21" name="Text 19"/>
+          <p:cNvSpPr txBox="1"/>
+          <p:nvPr/>
+        </p:nvSpPr>
+        <p:spPr>
+          <a:xfrm>
+            <a:off x="7680960" y="5257800"/>
+            <a:ext cx="3596335" cy="237744"/>
+          </a:xfrm>
+          <a:prstGeom prst="rect">
+            <a:avLst/>
+          </a:prstGeom>
+          <a:noFill/>
+          <a:ln/>
+        </p:spPr>
+        <p:txBody>
+          <a:bodyPr wrap="square" lIns="0" tIns="0" rIns="0" bIns="0" rtlCol="0" anchor="t"/>
+          <a:lstStyle/>
+          <a:p>
+            <a:pPr indent="0" marL="0">
+              <a:buNone/>
+            </a:pPr>
+            <a:r>
+              <a:rPr lang="en-US" sz="1100" spc="200" kern="0" dirty="0">
+                <a:solidFill>
+                  <a:srgbClr val="F6A623"/>
                 </a:solidFill>
                 <a:latin typeface="Consolas" pitchFamily="34" charset="0"/>
                 <a:ea typeface="Consolas" pitchFamily="34" charset="-122"/>
                 <a:cs typeface="Consolas" pitchFamily="34" charset="-120"/>
               </a:rPr>
-              <a:t>/docs#svg-rules  ·  /docs#svg-export</a:t>
-            </a:r>
-            <a:endParaRPr lang="en-US" sz="1200" dirty="0"/>
-          </a:p>
-        </p:txBody>
-      </p:sp>
-      <p:sp>
-        <p:nvSpPr>
-          <p:cNvPr id="19" name="Shape 17"/>
-          <p:cNvSpPr/>
-          <p:nvPr/>
-        </p:nvSpPr>
-        <p:spPr>
-          <a:xfrm>
-            <a:off x="7406640" y="3886200"/>
-            <a:ext cx="4144975" cy="2148840"/>
-          </a:xfrm>
-          <a:prstGeom prst="roundRect">
-            <a:avLst>
-              <a:gd name="adj" fmla="val 4255"/>
-            </a:avLst>
-          </a:prstGeom>
-          <a:solidFill>
-            <a:srgbClr val="141922"/>
-          </a:solidFill>
-          <a:ln/>
-        </p:spPr>
-      </p:sp>
-      <p:sp>
-        <p:nvSpPr>
-          <p:cNvPr id="20" name="Text 18"/>
-          <p:cNvSpPr txBox="1"/>
-          <p:nvPr/>
-        </p:nvSpPr>
-        <p:spPr>
-          <a:xfrm>
-            <a:off x="7607808" y="4087368"/>
-            <a:ext cx="3742639" cy="237744"/>
-          </a:xfrm>
-          <a:prstGeom prst="rect">
-            <a:avLst/>
-          </a:prstGeom>
-          <a:noFill/>
-          <a:ln/>
-        </p:spPr>
-        <p:txBody>
-          <a:bodyPr wrap="square" lIns="0" tIns="0" rIns="0" bIns="0" rtlCol="0" anchor="t"/>
-          <a:lstStyle/>
-          <a:p>
-            <a:pPr indent="0" marL="0">
-              <a:buNone/>
-            </a:pPr>
-            <a:r>
-              <a:rPr lang="en-US" sz="1100" spc="200" kern="0" dirty="0">
+              <a:t>THE GUIDE</a:t>
+            </a:r>
+            <a:endParaRPr lang="en-US" sz="1100" dirty="0"/>
+          </a:p>
+        </p:txBody>
+      </p:sp>
+      <p:sp>
+        <p:nvSpPr>
+          <p:cNvPr id="22" name="Text 20"/>
+          <p:cNvSpPr txBox="1"/>
+          <p:nvPr/>
+        </p:nvSpPr>
+        <p:spPr>
+          <a:xfrm>
+            <a:off x="7680960" y="5550408"/>
+            <a:ext cx="3596335" cy="320040"/>
+          </a:xfrm>
+          <a:prstGeom prst="rect">
+            <a:avLst/>
+          </a:prstGeom>
+          <a:noFill/>
+          <a:ln/>
+        </p:spPr>
+        <p:txBody>
+          <a:bodyPr wrap="square" lIns="0" tIns="0" rIns="0" bIns="0" rtlCol="0" anchor="t"/>
+          <a:lstStyle/>
+          <a:p>
+            <a:pPr indent="0" marL="0">
+              <a:buNone/>
+            </a:pPr>
+            <a:r>
+              <a:rPr lang="en-US" sz="1600" dirty="0">
                 <a:solidFill>
                   <a:srgbClr val="F6A623"/>
                 </a:solidFill>
@@ -4723,214 +4780,9 @@
                 <a:ea typeface="Consolas" pitchFamily="34" charset="-122"/>
                 <a:cs typeface="Consolas" pitchFamily="34" charset="-120"/>
               </a:rPr>
-              <a:t>SAY IT BEFORE THEY ASK</a:t>
-            </a:r>
-            <a:endParaRPr lang="en-US" sz="1100" dirty="0"/>
-          </a:p>
-        </p:txBody>
-      </p:sp>
-      <p:sp>
-        <p:nvSpPr>
-          <p:cNvPr id="21" name="Text 19"/>
-          <p:cNvSpPr txBox="1"/>
-          <p:nvPr/>
-        </p:nvSpPr>
-        <p:spPr>
-          <a:xfrm>
-            <a:off x="7607808" y="4379976"/>
-            <a:ext cx="3742639" cy="777240"/>
-          </a:xfrm>
-          <a:prstGeom prst="rect">
-            <a:avLst/>
-          </a:prstGeom>
-          <a:noFill/>
-          <a:ln/>
-        </p:spPr>
-        <p:txBody>
-          <a:bodyPr wrap="square" lIns="0" tIns="0" rIns="0" bIns="0" rtlCol="0" anchor="t"/>
-          <a:lstStyle/>
-          <a:p>
-            <a:pPr indent="0" marL="0">
-              <a:lnSpc>
-                <a:spcPct val="115000"/>
-              </a:lnSpc>
-              <a:buNone/>
-            </a:pPr>
-            <a:r>
-              <a:rPr lang="en-US" sz="1400" dirty="0">
-                <a:solidFill>
-                  <a:srgbClr val="C6CCD6"/>
-                </a:solidFill>
-                <a:latin typeface="Arial" pitchFamily="34" charset="0"/>
-                <a:ea typeface="Arial" pitchFamily="34" charset="-122"/>
-                <a:cs typeface="Arial" pitchFamily="34" charset="-120"/>
-              </a:rPr>
-              <a:t>If a long name does not grow the way you meant, the answer is one dropdown on the Fields step: </a:t>
-            </a:r>
-            <a:pPr indent="0" marL="0">
-              <a:lnSpc>
-                <a:spcPct val="115000"/>
-              </a:lnSpc>
-              <a:buNone/>
-            </a:pPr>
-            <a:r>
-              <a:rPr lang="en-US" sz="1400" b="1" dirty="0">
-                <a:solidFill>
-                  <a:srgbClr val="C6CCD6"/>
-                </a:solidFill>
-                <a:latin typeface="Arial" pitchFamily="34" charset="0"/>
-                <a:ea typeface="Arial" pitchFamily="34" charset="-122"/>
-                <a:cs typeface="Arial" pitchFamily="34" charset="-120"/>
-              </a:rPr>
-              <a:t>When the text is too long</a:t>
-            </a:r>
-            <a:pPr indent="0" marL="0">
-              <a:lnSpc>
-                <a:spcPct val="115000"/>
-              </a:lnSpc>
-              <a:buNone/>
-            </a:pPr>
-            <a:r>
-              <a:rPr lang="en-US" sz="1400" dirty="0">
-                <a:solidFill>
-                  <a:srgbClr val="C6CCD6"/>
-                </a:solidFill>
-                <a:latin typeface="Arial" pitchFamily="34" charset="0"/>
-                <a:ea typeface="Arial" pitchFamily="34" charset="-122"/>
-                <a:cs typeface="Arial" pitchFamily="34" charset="-120"/>
-              </a:rPr>
-              <a:t>.</a:t>
-            </a:r>
-            <a:endParaRPr lang="en-US" sz="1400" dirty="0"/>
-          </a:p>
-        </p:txBody>
-      </p:sp>
-      <p:sp>
-        <p:nvSpPr>
-          <p:cNvPr id="22" name="Text 20"/>
-          <p:cNvSpPr txBox="1"/>
-          <p:nvPr/>
-        </p:nvSpPr>
-        <p:spPr>
-          <a:xfrm>
-            <a:off x="7607808" y="5230368"/>
-            <a:ext cx="3742639" cy="777240"/>
-          </a:xfrm>
-          <a:prstGeom prst="rect">
-            <a:avLst/>
-          </a:prstGeom>
-          <a:noFill/>
-          <a:ln/>
-        </p:spPr>
-        <p:txBody>
-          <a:bodyPr wrap="square" lIns="0" tIns="0" rIns="0" bIns="0" rtlCol="0" anchor="t"/>
-          <a:lstStyle/>
-          <a:p>
-            <a:pPr indent="0" marL="0">
-              <a:lnSpc>
-                <a:spcPct val="115000"/>
-              </a:lnSpc>
-              <a:buNone/>
-            </a:pPr>
-            <a:r>
-              <a:rPr lang="en-US" sz="1400" dirty="0">
-                <a:solidFill>
-                  <a:srgbClr val="C6CCD6"/>
-                </a:solidFill>
-                <a:latin typeface="Arial" pitchFamily="34" charset="0"/>
-                <a:ea typeface="Arial" pitchFamily="34" charset="-122"/>
-                <a:cs typeface="Arial" pitchFamily="34" charset="-120"/>
-              </a:rPr>
-              <a:t>A typeface Google does not have, or a licensed one, takes the </a:t>
-            </a:r>
-            <a:pPr indent="0" marL="0">
-              <a:lnSpc>
-                <a:spcPct val="115000"/>
-              </a:lnSpc>
-              <a:buNone/>
-            </a:pPr>
-            <a:r>
-              <a:rPr lang="en-US" sz="1400" b="1" dirty="0">
-                <a:solidFill>
-                  <a:srgbClr val="C6CCD6"/>
-                </a:solidFill>
-                <a:latin typeface="Arial" pitchFamily="34" charset="0"/>
-                <a:ea typeface="Arial" pitchFamily="34" charset="-122"/>
-                <a:cs typeface="Arial" pitchFamily="34" charset="-120"/>
-              </a:rPr>
-              <a:t>upload</a:t>
-            </a:r>
-            <a:pPr indent="0" marL="0">
-              <a:lnSpc>
-                <a:spcPct val="115000"/>
-              </a:lnSpc>
-              <a:buNone/>
-            </a:pPr>
-            <a:r>
-              <a:rPr lang="en-US" sz="1400" dirty="0">
-                <a:solidFill>
-                  <a:srgbClr val="C6CCD6"/>
-                </a:solidFill>
-                <a:latin typeface="Arial" pitchFamily="34" charset="0"/>
-                <a:ea typeface="Arial" pitchFamily="34" charset="-122"/>
-                <a:cs typeface="Arial" pitchFamily="34" charset="-120"/>
-              </a:rPr>
-              <a:t> road in the Typefaces row, on the Fields step.</a:t>
-            </a:r>
-            <a:endParaRPr lang="en-US" sz="1400" dirty="0"/>
-          </a:p>
-        </p:txBody>
-      </p:sp>
-      <p:sp>
-        <p:nvSpPr>
-          <p:cNvPr id="23" name="Text 21"/>
-          <p:cNvSpPr txBox="1"/>
-          <p:nvPr/>
-        </p:nvSpPr>
-        <p:spPr>
-          <a:xfrm>
-            <a:off x="640080" y="6172200"/>
-            <a:ext cx="9814255" cy="274320"/>
-          </a:xfrm>
-          <a:prstGeom prst="rect">
-            <a:avLst/>
-          </a:prstGeom>
-          <a:noFill/>
-          <a:ln/>
-        </p:spPr>
-        <p:txBody>
-          <a:bodyPr wrap="square" lIns="0" tIns="0" rIns="0" bIns="0" rtlCol="0" anchor="t"/>
-          <a:lstStyle/>
-          <a:p>
-            <a:pPr indent="0" marL="0">
-              <a:buNone/>
-            </a:pPr>
-            <a:r>
-              <a:rPr lang="en-US" sz="1400" dirty="0">
-                <a:solidFill>
-                  <a:srgbClr val="6B7382"/>
-                </a:solidFill>
-                <a:latin typeface="Arial" pitchFamily="34" charset="0"/>
-                <a:ea typeface="Arial" pitchFamily="34" charset="-122"/>
-                <a:cs typeface="Arial" pitchFamily="34" charset="-120"/>
-              </a:rPr>
-              <a:t>The guide, step by step:  </a:t>
-            </a:r>
-            <a:pPr indent="0" marL="0">
-              <a:buNone/>
-            </a:pPr>
-            <a:r>
-              <a:rPr lang="en-US" sz="1400" dirty="0">
-                <a:solidFill>
-                  <a:srgbClr val="F6A623"/>
-                </a:solidFill>
-                <a:latin typeface="Consolas" pitchFamily="34" charset="0"/>
-                <a:ea typeface="Consolas" pitchFamily="34" charset="-122"/>
-                <a:cs typeface="Consolas" pitchFamily="34" charset="-120"/>
-              </a:rPr>
               <a:t>noacg.studio/docs#first-graphic</a:t>
             </a:r>
-            <a:endParaRPr lang="en-US" sz="1400" dirty="0"/>
+            <a:endParaRPr lang="en-US" sz="1600" dirty="0"/>
           </a:p>
         </p:txBody>
       </p:sp>
@@ -5254,7 +5106,7 @@
                 <a:ea typeface="Consolas" pitchFamily="34" charset="-122"/>
                 <a:cs typeface="Consolas" pitchFamily="34" charset="-120"/>
               </a:rPr>
-              <a:t># once; quiet after Allow? Ctrl-C is safe</a:t>
+              <a:t># once; a browser asks one question</a:t>
             </a:r>
             <a:pPr indent="0" marL="0">
               <a:lnSpc>
@@ -5297,7 +5149,7 @@
                 <a:ea typeface="Consolas" pitchFamily="34" charset="-122"/>
                 <a:cs typeface="Consolas" pitchFamily="34" charset="-120"/>
               </a:rPr>
-              <a:t># then open it from Home, Recent graphics</a:t>
+              <a:t># prints a link that opens at once</a:t>
             </a:r>
             <a:endParaRPr lang="en-US" sz="1400" dirty="0"/>
           </a:p>
@@ -5395,7 +5247,7 @@
                 <a:ea typeface="Arial" pitchFamily="34" charset="-122"/>
                 <a:cs typeface="Arial" pitchFamily="34" charset="-120"/>
               </a:rPr>
-              <a:t>, measured by hand on 2026-09-09. They all start a browser to reach the studio; validate is 10.7 s of it. Then save put a graphic in the live library in 9.3 s, on 2026-09-10. The hop from the library to air is still untimed.</a:t>
+              <a:t>, measured by hand on 2026-09-09. They all start a browser to reach the studio; validate is 10.7 s of it because it also runs the gate and writes three full-size frames. The rest of the clock is what the agent spends designing, plus the hop to a player. Nobody has put a stopwatch on that last leg end to end yet, so this is the number there is.</a:t>
             </a:r>
             <a:endParaRPr lang="en-US" sz="1450" dirty="0"/>
           </a:p>
@@ -5804,7 +5656,7 @@
                 <a:ea typeface="Consolas" pitchFamily="34" charset="-122"/>
                 <a:cs typeface="Consolas" pitchFamily="34" charset="-120"/>
               </a:rPr>
-              <a:t>ON AIR  ·  10 MIN  ·  EVERYONE, ON OUR OWN PLAYER</a:t>
+              <a:t>ON AIR  ·  20 MIN  ·  YOU DRIVE, THEN THE ROOM'S BOXES</a:t>
             </a:r>
             <a:endParaRPr lang="en-US" sz="1200" dirty="0"/>
           </a:p>
@@ -6286,22 +6138,17 @@
         <p:spPr>
           <a:xfrm>
             <a:off x="640080" y="3383280"/>
-            <a:ext cx="7589520" cy="2606040"/>
+            <a:ext cx="2590724" cy="2606040"/>
           </a:xfrm>
           <a:prstGeom prst="roundRect">
             <a:avLst>
-              <a:gd name="adj" fmla="val 3509"/>
+              <a:gd name="adj" fmla="val 3530"/>
             </a:avLst>
           </a:prstGeom>
           <a:solidFill>
             <a:srgbClr val="141922"/>
           </a:solidFill>
-          <a:ln w="19050">
-            <a:solidFill>
-              <a:srgbClr val="F6A623"/>
-            </a:solidFill>
-            <a:prstDash val="solid"/>
-          </a:ln>
+          <a:ln/>
         </p:spPr>
       </p:sp>
       <p:sp>
@@ -6313,23 +6160,23 @@
         <p:spPr>
           <a:xfrm>
             <a:off x="896112" y="3639312"/>
-            <a:ext cx="7077456" cy="237744"/>
-          </a:xfrm>
-          <a:prstGeom prst="rect">
-            <a:avLst/>
-          </a:prstGeom>
-          <a:noFill/>
-          <a:ln/>
-        </p:spPr>
-        <p:txBody>
-          <a:bodyPr wrap="square" lIns="0" tIns="0" rIns="0" bIns="0" rtlCol="0" anchor="t"/>
-          <a:lstStyle/>
-          <a:p>
-            <a:pPr indent="0" marL="0">
-              <a:buNone/>
-            </a:pPr>
-            <a:r>
-              <a:rPr lang="en-US" sz="1100" spc="200" kern="0" dirty="0">
+            <a:ext cx="2078660" cy="201168"/>
+          </a:xfrm>
+          <a:prstGeom prst="rect">
+            <a:avLst/>
+          </a:prstGeom>
+          <a:noFill/>
+          <a:ln/>
+        </p:spPr>
+        <p:txBody>
+          <a:bodyPr wrap="square" lIns="0" tIns="0" rIns="0" bIns="0" rtlCol="0" anchor="t"/>
+          <a:lstStyle/>
+          <a:p>
+            <a:pPr indent="0" marL="0">
+              <a:buNone/>
+            </a:pPr>
+            <a:r>
+              <a:rPr lang="en-US" sz="1050" spc="200" kern="0" dirty="0">
                 <a:solidFill>
                   <a:srgbClr val="F6A623"/>
                 </a:solidFill>
@@ -6337,9 +6184,9 @@
                 <a:ea typeface="Consolas" pitchFamily="34" charset="-122"/>
                 <a:cs typeface="Consolas" pitchFamily="34" charset="-120"/>
               </a:rPr>
-              <a:t>TODAY, THIS IS AIR</a:t>
-            </a:r>
-            <a:endParaRPr lang="en-US" sz="1100" dirty="0"/>
+              <a:t>EVERYONE</a:t>
+            </a:r>
+            <a:endParaRPr lang="en-US" sz="1050" dirty="0"/>
           </a:p>
         </p:txBody>
       </p:sp>
@@ -6351,24 +6198,27 @@
         </p:nvSpPr>
         <p:spPr>
           <a:xfrm>
-            <a:off x="896112" y="3968496"/>
-            <a:ext cx="7077456" cy="365760"/>
-          </a:xfrm>
-          <a:prstGeom prst="rect">
-            <a:avLst/>
-          </a:prstGeom>
-          <a:noFill/>
-          <a:ln/>
-        </p:spPr>
-        <p:txBody>
-          <a:bodyPr wrap="square" lIns="0" tIns="0" rIns="0" bIns="0" rtlCol="0" anchor="t"/>
-          <a:lstStyle/>
-          <a:p>
-            <a:pPr indent="0" marL="0">
-              <a:buNone/>
-            </a:pPr>
-            <a:r>
-              <a:rPr lang="en-US" sz="2200" b="1" dirty="0">
+            <a:off x="896112" y="3931920"/>
+            <a:ext cx="2078660" cy="685800"/>
+          </a:xfrm>
+          <a:prstGeom prst="rect">
+            <a:avLst/>
+          </a:prstGeom>
+          <a:noFill/>
+          <a:ln/>
+        </p:spPr>
+        <p:txBody>
+          <a:bodyPr wrap="square" lIns="0" tIns="0" rIns="0" bIns="0" rtlCol="0" anchor="t"/>
+          <a:lstStyle/>
+          <a:p>
+            <a:pPr indent="0" marL="0">
+              <a:lnSpc>
+                <a:spcPct val="105000"/>
+              </a:lnSpc>
+              <a:buNone/>
+            </a:pPr>
+            <a:r>
+              <a:rPr lang="en-US" sz="1800" b="1" dirty="0">
                 <a:solidFill>
                   <a:srgbClr val="E8EDF2"/>
                 </a:solidFill>
@@ -6376,9 +6226,9 @@
                 <a:ea typeface="Arial" pitchFamily="34" charset="-122"/>
                 <a:cs typeface="Arial" pitchFamily="34" charset="-120"/>
               </a:rPr>
-              <a:t>The output URL is the player.</a:t>
-            </a:r>
-            <a:endParaRPr lang="en-US" sz="2200" dirty="0"/>
+              <a:t>OBS, on your laptop</a:t>
+            </a:r>
+            <a:endParaRPr lang="en-US" sz="1800" dirty="0"/>
           </a:p>
         </p:txBody>
       </p:sp>
@@ -6390,8 +6240,8 @@
         </p:nvSpPr>
         <p:spPr>
           <a:xfrm>
-            <a:off x="896112" y="4425696"/>
-            <a:ext cx="7077456" cy="1188720"/>
+            <a:off x="896112" y="4645152"/>
+            <a:ext cx="2078660" cy="731520"/>
           </a:xfrm>
           <a:prstGeom prst="rect">
             <a:avLst/>
@@ -6410,7 +6260,7 @@
               <a:buNone/>
             </a:pPr>
             <a:r>
-              <a:rPr lang="en-US" sz="1600" dirty="0">
+              <a:rPr lang="en-US" sz="1400" dirty="0">
                 <a:solidFill>
                   <a:srgbClr val="C6CCD6"/>
                 </a:solidFill>
@@ -6418,9 +6268,9 @@
                 <a:ea typeface="Arial" pitchFamily="34" charset="-122"/>
                 <a:cs typeface="Arial" pitchFamily="34" charset="-120"/>
               </a:rPr>
-              <a:t>A browser tab on noacg.studio, playing your graphic at full size. Nothing to install, no box to configure, no setting to get right. Take a cue on the dashboard and it is up on the tab in front of the room.</a:t>
-            </a:r>
-            <a:endParaRPr lang="en-US" sz="1600" dirty="0"/>
+              <a:t>Browser source, the output URL, 1920x1080, your channel's fps.</a:t>
+            </a:r>
+            <a:endParaRPr lang="en-US" sz="1400" dirty="0"/>
           </a:p>
         </p:txBody>
       </p:sp>
@@ -6432,17 +6282,17 @@
         </p:nvSpPr>
         <p:spPr>
           <a:xfrm>
-            <a:off x="896112" y="5669280"/>
-            <a:ext cx="7077456" cy="228600"/>
-          </a:xfrm>
-          <a:prstGeom prst="rect">
-            <a:avLst/>
-          </a:prstGeom>
-          <a:noFill/>
-          <a:ln/>
-        </p:spPr>
-        <p:txBody>
-          <a:bodyPr wrap="square" lIns="0" tIns="0" rIns="0" bIns="0" rtlCol="0" anchor="t"/>
+            <a:off x="896112" y="5477256"/>
+            <a:ext cx="2078660" cy="256032"/>
+          </a:xfrm>
+          <a:prstGeom prst="rect">
+            <a:avLst/>
+          </a:prstGeom>
+          <a:noFill/>
+          <a:ln/>
+        </p:spPr>
+        <p:txBody>
+          <a:bodyPr wrap="square" lIns="0" tIns="0" rIns="0" bIns="0" rtlCol="0" anchor="b"/>
           <a:lstStyle/>
           <a:p>
             <a:pPr indent="0" marL="0">
@@ -6457,7 +6307,7 @@
                 <a:ea typeface="Consolas" pitchFamily="34" charset="-122"/>
                 <a:cs typeface="Consolas" pitchFamily="34" charset="-120"/>
               </a:rPr>
-              <a:t>/docs#dashboard</a:t>
+              <a:t>/docs#obs</a:t>
             </a:r>
             <a:endParaRPr lang="en-US" sz="1200" dirty="0"/>
           </a:p>
@@ -6471,12 +6321,12 @@
         </p:nvSpPr>
         <p:spPr>
           <a:xfrm>
-            <a:off x="8412480" y="3383280"/>
-            <a:ext cx="3139135" cy="2606040"/>
+            <a:off x="3413684" y="3383280"/>
+            <a:ext cx="2590724" cy="2606040"/>
           </a:xfrm>
           <a:prstGeom prst="roundRect">
             <a:avLst>
-              <a:gd name="adj" fmla="val 3509"/>
+              <a:gd name="adj" fmla="val 3530"/>
             </a:avLst>
           </a:prstGeom>
           <a:solidFill>
@@ -6493,24 +6343,24 @@
         </p:nvSpPr>
         <p:spPr>
           <a:xfrm>
-            <a:off x="8668512" y="3639312"/>
-            <a:ext cx="2627071" cy="237744"/>
-          </a:xfrm>
-          <a:prstGeom prst="rect">
-            <a:avLst/>
-          </a:prstGeom>
-          <a:noFill/>
-          <a:ln/>
-        </p:spPr>
-        <p:txBody>
-          <a:bodyPr wrap="square" lIns="0" tIns="0" rIns="0" bIns="0" rtlCol="0" anchor="t"/>
-          <a:lstStyle/>
-          <a:p>
-            <a:pPr indent="0" marL="0">
-              <a:buNone/>
-            </a:pPr>
-            <a:r>
-              <a:rPr lang="en-US" sz="1100" spc="200" kern="0" dirty="0">
+            <a:off x="3669716" y="3639312"/>
+            <a:ext cx="2078660" cy="201168"/>
+          </a:xfrm>
+          <a:prstGeom prst="rect">
+            <a:avLst/>
+          </a:prstGeom>
+          <a:noFill/>
+          <a:ln/>
+        </p:spPr>
+        <p:txBody>
+          <a:bodyPr wrap="square" lIns="0" tIns="0" rIns="0" bIns="0" rtlCol="0" anchor="t"/>
+          <a:lstStyle/>
+          <a:p>
+            <a:pPr indent="0" marL="0">
+              <a:buNone/>
+            </a:pPr>
+            <a:r>
+              <a:rPr lang="en-US" sz="1050" spc="200" kern="0" dirty="0">
                 <a:solidFill>
                   <a:srgbClr val="F6A623"/>
                 </a:solidFill>
@@ -6518,9 +6368,9 @@
                 <a:ea typeface="Consolas" pitchFamily="34" charset="-122"/>
                 <a:cs typeface="Consolas" pitchFamily="34" charset="-120"/>
               </a:rPr>
-              <a:t>NOT TODAY</a:t>
-            </a:r>
-            <a:endParaRPr lang="en-US" sz="1100" dirty="0"/>
+              <a:t>THE ROOM'S BOX</a:t>
+            </a:r>
+            <a:endParaRPr lang="en-US" sz="1050" dirty="0"/>
           </a:p>
         </p:txBody>
       </p:sp>
@@ -6532,24 +6382,27 @@
         </p:nvSpPr>
         <p:spPr>
           <a:xfrm>
-            <a:off x="8668512" y="3931920"/>
-            <a:ext cx="2627071" cy="274320"/>
-          </a:xfrm>
-          <a:prstGeom prst="rect">
-            <a:avLst/>
-          </a:prstGeom>
-          <a:noFill/>
-          <a:ln/>
-        </p:spPr>
-        <p:txBody>
-          <a:bodyPr wrap="square" lIns="0" tIns="0" rIns="0" bIns="0" rtlCol="0" anchor="t"/>
-          <a:lstStyle/>
-          <a:p>
-            <a:pPr indent="0" marL="0">
-              <a:buNone/>
-            </a:pPr>
-            <a:r>
-              <a:rPr lang="en-US" sz="1600" b="1" dirty="0">
+            <a:off x="3669716" y="3931920"/>
+            <a:ext cx="2078660" cy="685800"/>
+          </a:xfrm>
+          <a:prstGeom prst="rect">
+            <a:avLst/>
+          </a:prstGeom>
+          <a:noFill/>
+          <a:ln/>
+        </p:spPr>
+        <p:txBody>
+          <a:bodyPr wrap="square" lIns="0" tIns="0" rIns="0" bIns="0" rtlCol="0" anchor="t"/>
+          <a:lstStyle/>
+          <a:p>
+            <a:pPr indent="0" marL="0">
+              <a:lnSpc>
+                <a:spcPct val="105000"/>
+              </a:lnSpc>
+              <a:buNone/>
+            </a:pPr>
+            <a:r>
+              <a:rPr lang="en-US" sz="1800" b="1" dirty="0">
                 <a:solidFill>
                   <a:srgbClr val="E8EDF2"/>
                 </a:solidFill>
@@ -6557,9 +6410,9 @@
                 <a:ea typeface="Arial" pitchFamily="34" charset="-122"/>
                 <a:cs typeface="Arial" pitchFamily="34" charset="-120"/>
               </a:rPr>
-              <a:t>Your own systems, later</a:t>
-            </a:r>
-            <a:endParaRPr lang="en-US" sz="1600" dirty="0"/>
+              <a:t>CasparCG 2.3, the URL</a:t>
+            </a:r>
+            <a:endParaRPr lang="en-US" sz="1800" dirty="0"/>
           </a:p>
         </p:txBody>
       </p:sp>
@@ -6571,8 +6424,8 @@
         </p:nvSpPr>
         <p:spPr>
           <a:xfrm>
-            <a:off x="8668512" y="4315968"/>
-            <a:ext cx="2627071" cy="1325880"/>
+            <a:off x="3669716" y="4645152"/>
+            <a:ext cx="2078660" cy="731520"/>
           </a:xfrm>
           <a:prstGeom prst="rect">
             <a:avLst/>
@@ -6591,7 +6444,7 @@
               <a:buNone/>
             </a:pPr>
             <a:r>
-              <a:rPr lang="en-US" sz="1300" dirty="0">
+              <a:rPr lang="en-US" sz="1400" dirty="0">
                 <a:solidFill>
                   <a:srgbClr val="C6CCD6"/>
                 </a:solidFill>
@@ -6599,9 +6452,9 @@
                 <a:ea typeface="Arial" pitchFamily="34" charset="-122"/>
                 <a:cs typeface="Arial" pitchFamily="34" charset="-120"/>
               </a:rPr>
-              <a:t>OBS, a CasparCG box, an SPX rundown, an OGraf renderer. Each is a package or a URL away and written up, for a studio session rather than a room of laptops.</a:t>
-            </a:r>
-            <a:endParaRPr lang="en-US" sz="1300" dirty="0"/>
+              <a:t>CG 1-20 ADD 1 "&lt;URL&gt;" 1, loaded once, then cued from the dashboard.</a:t>
+            </a:r>
+            <a:endParaRPr lang="en-US" sz="1400" dirty="0"/>
           </a:p>
         </p:txBody>
       </p:sp>
@@ -6613,17 +6466,17 @@
         </p:nvSpPr>
         <p:spPr>
           <a:xfrm>
-            <a:off x="8668512" y="5669280"/>
-            <a:ext cx="2627071" cy="228600"/>
-          </a:xfrm>
-          <a:prstGeom prst="rect">
-            <a:avLst/>
-          </a:prstGeom>
-          <a:noFill/>
-          <a:ln/>
-        </p:spPr>
-        <p:txBody>
-          <a:bodyPr wrap="square" lIns="0" tIns="0" rIns="0" bIns="0" rtlCol="0" anchor="t"/>
+            <a:off x="3669716" y="5477256"/>
+            <a:ext cx="2078660" cy="256032"/>
+          </a:xfrm>
+          <a:prstGeom prst="rect">
+            <a:avLst/>
+          </a:prstGeom>
+          <a:noFill/>
+          <a:ln/>
+        </p:spPr>
+        <p:txBody>
+          <a:bodyPr wrap="square" lIns="0" tIns="0" rIns="0" bIns="0" rtlCol="0" anchor="b"/>
           <a:lstStyle/>
           <a:p>
             <a:pPr indent="0" marL="0">
@@ -6638,6 +6491,190 @@
                 <a:ea typeface="Consolas" pitchFamily="34" charset="-122"/>
                 <a:cs typeface="Consolas" pitchFamily="34" charset="-120"/>
               </a:rPr>
+              <a:t>/docs#casparcg-url</a:t>
+            </a:r>
+            <a:endParaRPr lang="en-US" sz="1200" dirty="0"/>
+          </a:p>
+        </p:txBody>
+      </p:sp>
+      <p:sp>
+        <p:nvSpPr>
+          <p:cNvPr id="24" name="Shape 22"/>
+          <p:cNvSpPr/>
+          <p:nvPr/>
+        </p:nvSpPr>
+        <p:spPr>
+          <a:xfrm>
+            <a:off x="6187288" y="3383280"/>
+            <a:ext cx="2590724" cy="2606040"/>
+          </a:xfrm>
+          <a:prstGeom prst="roundRect">
+            <a:avLst>
+              <a:gd name="adj" fmla="val 3530"/>
+            </a:avLst>
+          </a:prstGeom>
+          <a:solidFill>
+            <a:srgbClr val="141922"/>
+          </a:solidFill>
+          <a:ln/>
+        </p:spPr>
+      </p:sp>
+      <p:sp>
+        <p:nvSpPr>
+          <p:cNvPr id="25" name="Text 23"/>
+          <p:cNvSpPr txBox="1"/>
+          <p:nvPr/>
+        </p:nvSpPr>
+        <p:spPr>
+          <a:xfrm>
+            <a:off x="6443320" y="3639312"/>
+            <a:ext cx="2078660" cy="201168"/>
+          </a:xfrm>
+          <a:prstGeom prst="rect">
+            <a:avLst/>
+          </a:prstGeom>
+          <a:noFill/>
+          <a:ln/>
+        </p:spPr>
+        <p:txBody>
+          <a:bodyPr wrap="square" lIns="0" tIns="0" rIns="0" bIns="0" rtlCol="0" anchor="t"/>
+          <a:lstStyle/>
+          <a:p>
+            <a:pPr indent="0" marL="0">
+              <a:buNone/>
+            </a:pPr>
+            <a:r>
+              <a:rPr lang="en-US" sz="1050" spc="200" kern="0" dirty="0">
+                <a:solidFill>
+                  <a:srgbClr val="F6A623"/>
+                </a:solidFill>
+                <a:latin typeface="Consolas" pitchFamily="34" charset="0"/>
+                <a:ea typeface="Consolas" pitchFamily="34" charset="-122"/>
+                <a:cs typeface="Consolas" pitchFamily="34" charset="-120"/>
+              </a:rPr>
+              <a:t>NO NETWORK</a:t>
+            </a:r>
+            <a:endParaRPr lang="en-US" sz="1050" dirty="0"/>
+          </a:p>
+        </p:txBody>
+      </p:sp>
+      <p:sp>
+        <p:nvSpPr>
+          <p:cNvPr id="26" name="Text 24"/>
+          <p:cNvSpPr txBox="1"/>
+          <p:nvPr/>
+        </p:nvSpPr>
+        <p:spPr>
+          <a:xfrm>
+            <a:off x="6443320" y="3931920"/>
+            <a:ext cx="2078660" cy="685800"/>
+          </a:xfrm>
+          <a:prstGeom prst="rect">
+            <a:avLst/>
+          </a:prstGeom>
+          <a:noFill/>
+          <a:ln/>
+        </p:spPr>
+        <p:txBody>
+          <a:bodyPr wrap="square" lIns="0" tIns="0" rIns="0" bIns="0" rtlCol="0" anchor="t"/>
+          <a:lstStyle/>
+          <a:p>
+            <a:pPr indent="0" marL="0">
+              <a:lnSpc>
+                <a:spcPct val="105000"/>
+              </a:lnSpc>
+              <a:buNone/>
+            </a:pPr>
+            <a:r>
+              <a:rPr lang="en-US" sz="1800" b="1" dirty="0">
+                <a:solidFill>
+                  <a:srgbClr val="E8EDF2"/>
+                </a:solidFill>
+                <a:latin typeface="Arial" pitchFamily="34" charset="0"/>
+                <a:ea typeface="Arial" pitchFamily="34" charset="-122"/>
+                <a:cs typeface="Arial" pitchFamily="34" charset="-120"/>
+              </a:rPr>
+              <a:t>CasparCG or SPX, a file</a:t>
+            </a:r>
+            <a:endParaRPr lang="en-US" sz="1800" dirty="0"/>
+          </a:p>
+        </p:txBody>
+      </p:sp>
+      <p:sp>
+        <p:nvSpPr>
+          <p:cNvPr id="27" name="Text 25"/>
+          <p:cNvSpPr txBox="1"/>
+          <p:nvPr/>
+        </p:nvSpPr>
+        <p:spPr>
+          <a:xfrm>
+            <a:off x="6443320" y="4645152"/>
+            <a:ext cx="2078660" cy="731520"/>
+          </a:xfrm>
+          <a:prstGeom prst="rect">
+            <a:avLst/>
+          </a:prstGeom>
+          <a:noFill/>
+          <a:ln/>
+        </p:spPr>
+        <p:txBody>
+          <a:bodyPr wrap="square" lIns="0" tIns="0" rIns="0" bIns="0" rtlCol="0" anchor="t"/>
+          <a:lstStyle/>
+          <a:p>
+            <a:pPr indent="0" marL="0">
+              <a:lnSpc>
+                <a:spcPct val="115000"/>
+              </a:lnSpc>
+              <a:buNone/>
+            </a:pPr>
+            <a:r>
+              <a:rPr lang="en-US" sz="1400" dirty="0">
+                <a:solidFill>
+                  <a:srgbClr val="C6CCD6"/>
+                </a:solidFill>
+                <a:latin typeface="Arial" pitchFamily="34" charset="0"/>
+                <a:ea typeface="Arial" pitchFamily="34" charset="-122"/>
+                <a:cs typeface="Arial" pitchFamily="34" charset="-120"/>
+              </a:rPr>
+              <a:t>Export the package, play the file, drive it from the bundled control panel.</a:t>
+            </a:r>
+            <a:endParaRPr lang="en-US" sz="1400" dirty="0"/>
+          </a:p>
+        </p:txBody>
+      </p:sp>
+      <p:sp>
+        <p:nvSpPr>
+          <p:cNvPr id="28" name="Text 26"/>
+          <p:cNvSpPr txBox="1"/>
+          <p:nvPr/>
+        </p:nvSpPr>
+        <p:spPr>
+          <a:xfrm>
+            <a:off x="6443320" y="5477256"/>
+            <a:ext cx="2078660" cy="256032"/>
+          </a:xfrm>
+          <a:prstGeom prst="rect">
+            <a:avLst/>
+          </a:prstGeom>
+          <a:noFill/>
+          <a:ln/>
+        </p:spPr>
+        <p:txBody>
+          <a:bodyPr wrap="square" lIns="0" tIns="0" rIns="0" bIns="0" rtlCol="0" anchor="b"/>
+          <a:lstStyle/>
+          <a:p>
+            <a:pPr indent="0" marL="0">
+              <a:buNone/>
+            </a:pPr>
+            <a:r>
+              <a:rPr lang="en-US" sz="1200" dirty="0">
+                <a:solidFill>
+                  <a:srgbClr val="E8EDF2"/>
+                </a:solidFill>
+                <a:latin typeface="Consolas" pitchFamily="34" charset="0"/>
+                <a:ea typeface="Consolas" pitchFamily="34" charset="-122"/>
+                <a:cs typeface="Consolas" pitchFamily="34" charset="-120"/>
+              </a:rPr>
               <a:t>/docs#export</a:t>
             </a:r>
             <a:endParaRPr lang="en-US" sz="1200" dirty="0"/>
@@ -6646,7 +6683,191 @@
       </p:sp>
       <p:sp>
         <p:nvSpPr>
-          <p:cNvPr id="24" name="Text 22"/>
+          <p:cNvPr id="29" name="Shape 27"/>
+          <p:cNvSpPr/>
+          <p:nvPr/>
+        </p:nvSpPr>
+        <p:spPr>
+          <a:xfrm>
+            <a:off x="8960891" y="3383280"/>
+            <a:ext cx="2590724" cy="2606040"/>
+          </a:xfrm>
+          <a:prstGeom prst="roundRect">
+            <a:avLst>
+              <a:gd name="adj" fmla="val 3530"/>
+            </a:avLst>
+          </a:prstGeom>
+          <a:solidFill>
+            <a:srgbClr val="141922"/>
+          </a:solidFill>
+          <a:ln/>
+        </p:spPr>
+      </p:sp>
+      <p:sp>
+        <p:nvSpPr>
+          <p:cNvPr id="30" name="Text 28"/>
+          <p:cNvSpPr txBox="1"/>
+          <p:nvPr/>
+        </p:nvSpPr>
+        <p:spPr>
+          <a:xfrm>
+            <a:off x="9216923" y="3639312"/>
+            <a:ext cx="2078660" cy="201168"/>
+          </a:xfrm>
+          <a:prstGeom prst="rect">
+            <a:avLst/>
+          </a:prstGeom>
+          <a:noFill/>
+          <a:ln/>
+        </p:spPr>
+        <p:txBody>
+          <a:bodyPr wrap="square" lIns="0" tIns="0" rIns="0" bIns="0" rtlCol="0" anchor="t"/>
+          <a:lstStyle/>
+          <a:p>
+            <a:pPr indent="0" marL="0">
+              <a:buNone/>
+            </a:pPr>
+            <a:r>
+              <a:rPr lang="en-US" sz="1050" spc="200" kern="0" dirty="0">
+                <a:solidFill>
+                  <a:srgbClr val="F6A623"/>
+                </a:solidFill>
+                <a:latin typeface="Consolas" pitchFamily="34" charset="0"/>
+                <a:ea typeface="Consolas" pitchFamily="34" charset="-122"/>
+                <a:cs typeface="Consolas" pitchFamily="34" charset="-120"/>
+              </a:rPr>
+              <a:t>FOR YLE</a:t>
+            </a:r>
+            <a:endParaRPr lang="en-US" sz="1050" dirty="0"/>
+          </a:p>
+        </p:txBody>
+      </p:sp>
+      <p:sp>
+        <p:nvSpPr>
+          <p:cNvPr id="31" name="Text 29"/>
+          <p:cNvSpPr txBox="1"/>
+          <p:nvPr/>
+        </p:nvSpPr>
+        <p:spPr>
+          <a:xfrm>
+            <a:off x="9216923" y="3931920"/>
+            <a:ext cx="2078660" cy="685800"/>
+          </a:xfrm>
+          <a:prstGeom prst="rect">
+            <a:avLst/>
+          </a:prstGeom>
+          <a:noFill/>
+          <a:ln/>
+        </p:spPr>
+        <p:txBody>
+          <a:bodyPr wrap="square" lIns="0" tIns="0" rIns="0" bIns="0" rtlCol="0" anchor="t"/>
+          <a:lstStyle/>
+          <a:p>
+            <a:pPr indent="0" marL="0">
+              <a:lnSpc>
+                <a:spcPct val="105000"/>
+              </a:lnSpc>
+              <a:buNone/>
+            </a:pPr>
+            <a:r>
+              <a:rPr lang="en-US" sz="1800" b="1" dirty="0">
+                <a:solidFill>
+                  <a:srgbClr val="E8EDF2"/>
+                </a:solidFill>
+                <a:latin typeface="Arial" pitchFamily="34" charset="0"/>
+                <a:ea typeface="Arial" pitchFamily="34" charset="-122"/>
+                <a:cs typeface="Arial" pitchFamily="34" charset="-120"/>
+              </a:rPr>
+              <a:t>An OGraf renderer</a:t>
+            </a:r>
+            <a:endParaRPr lang="en-US" sz="1800" dirty="0"/>
+          </a:p>
+        </p:txBody>
+      </p:sp>
+      <p:sp>
+        <p:nvSpPr>
+          <p:cNvPr id="32" name="Text 30"/>
+          <p:cNvSpPr txBox="1"/>
+          <p:nvPr/>
+        </p:nvSpPr>
+        <p:spPr>
+          <a:xfrm>
+            <a:off x="9216923" y="4645152"/>
+            <a:ext cx="2078660" cy="731520"/>
+          </a:xfrm>
+          <a:prstGeom prst="rect">
+            <a:avLst/>
+          </a:prstGeom>
+          <a:noFill/>
+          <a:ln/>
+        </p:spPr>
+        <p:txBody>
+          <a:bodyPr wrap="square" lIns="0" tIns="0" rIns="0" bIns="0" rtlCol="0" anchor="t"/>
+          <a:lstStyle/>
+          <a:p>
+            <a:pPr indent="0" marL="0">
+              <a:lnSpc>
+                <a:spcPct val="115000"/>
+              </a:lnSpc>
+              <a:buNone/>
+            </a:pPr>
+            <a:r>
+              <a:rPr lang="en-US" sz="1400" dirty="0">
+                <a:solidFill>
+                  <a:srgbClr val="C6CCD6"/>
+                </a:solidFill>
+                <a:latin typeface="Arial" pitchFamily="34" charset="0"/>
+                <a:ea typeface="Arial" pitchFamily="34" charset="-122"/>
+                <a:cs typeface="Arial" pitchFamily="34" charset="-120"/>
+              </a:rPr>
+              <a:t>Export as an OGraf package, or take a starter from noacg.studio/ograf.</a:t>
+            </a:r>
+            <a:endParaRPr lang="en-US" sz="1400" dirty="0"/>
+          </a:p>
+        </p:txBody>
+      </p:sp>
+      <p:sp>
+        <p:nvSpPr>
+          <p:cNvPr id="33" name="Text 31"/>
+          <p:cNvSpPr txBox="1"/>
+          <p:nvPr/>
+        </p:nvSpPr>
+        <p:spPr>
+          <a:xfrm>
+            <a:off x="9216923" y="5477256"/>
+            <a:ext cx="2078660" cy="256032"/>
+          </a:xfrm>
+          <a:prstGeom prst="rect">
+            <a:avLst/>
+          </a:prstGeom>
+          <a:noFill/>
+          <a:ln/>
+        </p:spPr>
+        <p:txBody>
+          <a:bodyPr wrap="square" lIns="0" tIns="0" rIns="0" bIns="0" rtlCol="0" anchor="b"/>
+          <a:lstStyle/>
+          <a:p>
+            <a:pPr indent="0" marL="0">
+              <a:buNone/>
+            </a:pPr>
+            <a:r>
+              <a:rPr lang="en-US" sz="1200" dirty="0">
+                <a:solidFill>
+                  <a:srgbClr val="E8EDF2"/>
+                </a:solidFill>
+                <a:latin typeface="Consolas" pitchFamily="34" charset="0"/>
+                <a:ea typeface="Consolas" pitchFamily="34" charset="-122"/>
+                <a:cs typeface="Consolas" pitchFamily="34" charset="-120"/>
+              </a:rPr>
+              <a:t>noacg.studio/ograf</a:t>
+            </a:r>
+            <a:endParaRPr lang="en-US" sz="1200" dirty="0"/>
+          </a:p>
+        </p:txBody>
+      </p:sp>
+      <p:sp>
+        <p:nvSpPr>
+          <p:cNvPr id="34" name="Text 32"/>
           <p:cNvSpPr txBox="1"/>
           <p:nvPr/>
         </p:nvSpPr>
@@ -6841,7 +7062,7 @@
         <p:spPr>
           <a:xfrm>
             <a:off x="640080" y="1783080"/>
-            <a:ext cx="5394960" cy="731520"/>
+            <a:ext cx="10911535" cy="731520"/>
           </a:xfrm>
           <a:prstGeom prst="rect">
             <a:avLst/>
@@ -6873,36 +7094,14 @@
       </p:sp>
       <p:sp>
         <p:nvSpPr>
-          <p:cNvPr id="6" name="Shape 4"/>
-          <p:cNvSpPr/>
-          <p:nvPr/>
-        </p:nvSpPr>
-        <p:spPr>
-          <a:xfrm>
-            <a:off x="6309360" y="1691640"/>
-            <a:ext cx="5242255" cy="1508760"/>
-          </a:xfrm>
-          <a:prstGeom prst="roundRect">
-            <a:avLst>
-              <a:gd name="adj" fmla="val 6061"/>
-            </a:avLst>
-          </a:prstGeom>
-          <a:solidFill>
-            <a:srgbClr val="141922"/>
-          </a:solidFill>
-          <a:ln/>
-        </p:spPr>
-      </p:sp>
-      <p:sp>
-        <p:nvSpPr>
-          <p:cNvPr id="7" name="Text 5"/>
-          <p:cNvSpPr txBox="1"/>
-          <p:nvPr/>
-        </p:nvSpPr>
-        <p:spPr>
-          <a:xfrm>
-            <a:off x="6510528" y="1892808"/>
-            <a:ext cx="4839919" cy="237744"/>
+          <p:cNvPr id="6" name="Text 4"/>
+          <p:cNvSpPr txBox="1"/>
+          <p:nvPr/>
+        </p:nvSpPr>
+        <p:spPr>
+          <a:xfrm>
+            <a:off x="640080" y="2971800"/>
+            <a:ext cx="3454298" cy="237744"/>
           </a:xfrm>
           <a:prstGeom prst="rect">
             <a:avLst/>
@@ -6926,7 +7125,7 @@
                 <a:ea typeface="Consolas" pitchFamily="34" charset="-122"/>
                 <a:cs typeface="Consolas" pitchFamily="34" charset="-120"/>
               </a:rPr>
-              <a:t>IN YOUR HAND, AND AFTERWARDS A FILE</a:t>
+              <a:t>ROAD 1</a:t>
             </a:r>
             <a:endParaRPr lang="en-US" sz="1100" dirty="0"/>
           </a:p>
@@ -6934,83 +7133,350 @@
       </p:sp>
       <p:sp>
         <p:nvSpPr>
+          <p:cNvPr id="7" name="Text 5"/>
+          <p:cNvSpPr txBox="1"/>
+          <p:nvPr/>
+        </p:nvSpPr>
+        <p:spPr>
+          <a:xfrm>
+            <a:off x="640080" y="3337560"/>
+            <a:ext cx="3454298" cy="292608"/>
+          </a:xfrm>
+          <a:prstGeom prst="rect">
+            <a:avLst/>
+          </a:prstGeom>
+          <a:noFill/>
+          <a:ln/>
+        </p:spPr>
+        <p:txBody>
+          <a:bodyPr wrap="square" lIns="0" tIns="0" rIns="0" bIns="0" rtlCol="0" anchor="t"/>
+          <a:lstStyle/>
+          <a:p>
+            <a:pPr indent="0" marL="0">
+              <a:buNone/>
+            </a:pPr>
+            <a:r>
+              <a:rPr lang="en-US" sz="1800" dirty="0">
+                <a:solidFill>
+                  <a:srgbClr val="E8EDF2"/>
+                </a:solidFill>
+                <a:latin typeface="Consolas" pitchFamily="34" charset="0"/>
+                <a:ea typeface="Consolas" pitchFamily="34" charset="-122"/>
+                <a:cs typeface="Consolas" pitchFamily="34" charset="-120"/>
+              </a:rPr>
+              <a:t>#first-graphic</a:t>
+            </a:r>
+            <a:endParaRPr lang="en-US" sz="1800" dirty="0"/>
+          </a:p>
+        </p:txBody>
+      </p:sp>
+      <p:sp>
+        <p:nvSpPr>
           <p:cNvPr id="8" name="Text 6"/>
           <p:cNvSpPr txBox="1"/>
           <p:nvPr/>
         </p:nvSpPr>
         <p:spPr>
           <a:xfrm>
-            <a:off x="6510528" y="2185416"/>
-            <a:ext cx="4839919" cy="950976"/>
-          </a:xfrm>
-          <a:prstGeom prst="rect">
-            <a:avLst/>
-          </a:prstGeom>
-          <a:noFill/>
-          <a:ln/>
-        </p:spPr>
-        <p:txBody>
-          <a:bodyPr wrap="square" lIns="0" tIns="0" rIns="0" bIns="0" rtlCol="0" anchor="t"/>
-          <a:lstStyle/>
-          <a:p>
-            <a:pPr indent="0" marL="0">
-              <a:buNone/>
-            </a:pPr>
-            <a:r>
-              <a:rPr lang="en-US" sz="1400" b="1" dirty="0">
-                <a:solidFill>
-                  <a:srgbClr val="E8EDF2"/>
+            <a:off x="640080" y="3648456"/>
+            <a:ext cx="3454298" cy="274320"/>
+          </a:xfrm>
+          <a:prstGeom prst="rect">
+            <a:avLst/>
+          </a:prstGeom>
+          <a:noFill/>
+          <a:ln/>
+        </p:spPr>
+        <p:txBody>
+          <a:bodyPr wrap="square" lIns="0" tIns="0" rIns="0" bIns="0" rtlCol="0" anchor="t"/>
+          <a:lstStyle/>
+          <a:p>
+            <a:pPr indent="0" marL="0">
+              <a:buNone/>
+            </a:pPr>
+            <a:r>
+              <a:rPr lang="en-US" sz="1400" dirty="0">
+                <a:solidFill>
+                  <a:srgbClr val="8B98A8"/>
                 </a:solidFill>
                 <a:latin typeface="Arial" pitchFamily="34" charset="0"/>
                 <a:ea typeface="Arial" pitchFamily="34" charset="-122"/>
                 <a:cs typeface="Arial" pitchFamily="34" charset="-120"/>
               </a:rPr>
-              <a:t>For the room</a:t>
-            </a:r>
+              <a:t>the whole road, step by step</a:t>
+            </a:r>
+            <a:endParaRPr lang="en-US" sz="1400" dirty="0"/>
+          </a:p>
+        </p:txBody>
+      </p:sp>
+      <p:sp>
+        <p:nvSpPr>
+          <p:cNvPr id="9" name="Text 7"/>
+          <p:cNvSpPr txBox="1"/>
+          <p:nvPr/>
+        </p:nvSpPr>
+        <p:spPr>
+          <a:xfrm>
+            <a:off x="640080" y="3977640"/>
+            <a:ext cx="3454298" cy="292608"/>
+          </a:xfrm>
+          <a:prstGeom prst="rect">
+            <a:avLst/>
+          </a:prstGeom>
+          <a:noFill/>
+          <a:ln/>
+        </p:spPr>
+        <p:txBody>
+          <a:bodyPr wrap="square" lIns="0" tIns="0" rIns="0" bIns="0" rtlCol="0" anchor="t"/>
+          <a:lstStyle/>
+          <a:p>
+            <a:pPr indent="0" marL="0">
+              <a:buNone/>
+            </a:pPr>
+            <a:r>
+              <a:rPr lang="en-US" sz="1800" dirty="0">
+                <a:solidFill>
+                  <a:srgbClr val="E8EDF2"/>
+                </a:solidFill>
+                <a:latin typeface="Consolas" pitchFamily="34" charset="0"/>
+                <a:ea typeface="Consolas" pitchFamily="34" charset="-122"/>
+                <a:cs typeface="Consolas" pitchFamily="34" charset="-120"/>
+              </a:rPr>
+              <a:t>#svg</a:t>
+            </a:r>
+            <a:endParaRPr lang="en-US" sz="1800" dirty="0"/>
+          </a:p>
+        </p:txBody>
+      </p:sp>
+      <p:sp>
+        <p:nvSpPr>
+          <p:cNvPr id="10" name="Text 8"/>
+          <p:cNvSpPr txBox="1"/>
+          <p:nvPr/>
+        </p:nvSpPr>
+        <p:spPr>
+          <a:xfrm>
+            <a:off x="640080" y="4288536"/>
+            <a:ext cx="3454298" cy="274320"/>
+          </a:xfrm>
+          <a:prstGeom prst="rect">
+            <a:avLst/>
+          </a:prstGeom>
+          <a:noFill/>
+          <a:ln/>
+        </p:spPr>
+        <p:txBody>
+          <a:bodyPr wrap="square" lIns="0" tIns="0" rIns="0" bIns="0" rtlCol="0" anchor="t"/>
+          <a:lstStyle/>
+          <a:p>
             <a:pPr indent="0" marL="0">
               <a:buNone/>
             </a:pPr>
             <a:r>
               <a:rPr lang="en-US" sz="1400" dirty="0">
                 <a:solidFill>
-                  <a:srgbClr val="C6CCD6"/>
+                  <a:srgbClr val="8B98A8"/>
                 </a:solidFill>
                 <a:latin typeface="Arial" pitchFamily="34" charset="0"/>
                 <a:ea typeface="Arial" pitchFamily="34" charset="-122"/>
                 <a:cs typeface="Arial" pitchFamily="34" charset="-120"/>
               </a:rPr>
-              <a:t> - the road in order, both URLs, a link into every section below, and the take-home brief.</a:t>
+              <a:t>rules, layers, fonts, export</a:t>
             </a:r>
             <a:endParaRPr lang="en-US" sz="1400" dirty="0"/>
           </a:p>
-          <a:p>
-            <a:pPr indent="0" marL="0">
-              <a:buNone/>
-            </a:pPr>
-            <a:r>
-              <a:rPr lang="en-US" sz="1400" b="1" dirty="0">
+        </p:txBody>
+      </p:sp>
+      <p:sp>
+        <p:nvSpPr>
+          <p:cNvPr id="11" name="Text 9"/>
+          <p:cNvSpPr txBox="1"/>
+          <p:nvPr/>
+        </p:nvSpPr>
+        <p:spPr>
+          <a:xfrm>
+            <a:off x="4368698" y="2971800"/>
+            <a:ext cx="3454298" cy="237744"/>
+          </a:xfrm>
+          <a:prstGeom prst="rect">
+            <a:avLst/>
+          </a:prstGeom>
+          <a:noFill/>
+          <a:ln/>
+        </p:spPr>
+        <p:txBody>
+          <a:bodyPr wrap="square" lIns="0" tIns="0" rIns="0" bIns="0" rtlCol="0" anchor="t"/>
+          <a:lstStyle/>
+          <a:p>
+            <a:pPr indent="0" marL="0">
+              <a:buNone/>
+            </a:pPr>
+            <a:r>
+              <a:rPr lang="en-US" sz="1100" spc="200" kern="0" dirty="0">
+                <a:solidFill>
+                  <a:srgbClr val="F6A623"/>
+                </a:solidFill>
+                <a:latin typeface="Consolas" pitchFamily="34" charset="0"/>
+                <a:ea typeface="Consolas" pitchFamily="34" charset="-122"/>
+                <a:cs typeface="Consolas" pitchFamily="34" charset="-120"/>
+              </a:rPr>
+              <a:t>ROAD 2</a:t>
+            </a:r>
+            <a:endParaRPr lang="en-US" sz="1100" dirty="0"/>
+          </a:p>
+        </p:txBody>
+      </p:sp>
+      <p:sp>
+        <p:nvSpPr>
+          <p:cNvPr id="12" name="Text 10"/>
+          <p:cNvSpPr txBox="1"/>
+          <p:nvPr/>
+        </p:nvSpPr>
+        <p:spPr>
+          <a:xfrm>
+            <a:off x="4368698" y="3337560"/>
+            <a:ext cx="3454298" cy="292608"/>
+          </a:xfrm>
+          <a:prstGeom prst="rect">
+            <a:avLst/>
+          </a:prstGeom>
+          <a:noFill/>
+          <a:ln/>
+        </p:spPr>
+        <p:txBody>
+          <a:bodyPr wrap="square" lIns="0" tIns="0" rIns="0" bIns="0" rtlCol="0" anchor="t"/>
+          <a:lstStyle/>
+          <a:p>
+            <a:pPr indent="0" marL="0">
+              <a:buNone/>
+            </a:pPr>
+            <a:r>
+              <a:rPr lang="en-US" sz="1800" dirty="0">
                 <a:solidFill>
                   <a:srgbClr val="E8EDF2"/>
+                </a:solidFill>
+                <a:latin typeface="Consolas" pitchFamily="34" charset="0"/>
+                <a:ea typeface="Consolas" pitchFamily="34" charset="-122"/>
+                <a:cs typeface="Consolas" pitchFamily="34" charset="-120"/>
+              </a:rPr>
+              <a:t>#claude-code</a:t>
+            </a:r>
+            <a:endParaRPr lang="en-US" sz="1800" dirty="0"/>
+          </a:p>
+        </p:txBody>
+      </p:sp>
+      <p:sp>
+        <p:nvSpPr>
+          <p:cNvPr id="13" name="Text 11"/>
+          <p:cNvSpPr txBox="1"/>
+          <p:nvPr/>
+        </p:nvSpPr>
+        <p:spPr>
+          <a:xfrm>
+            <a:off x="4368698" y="3648456"/>
+            <a:ext cx="3454298" cy="274320"/>
+          </a:xfrm>
+          <a:prstGeom prst="rect">
+            <a:avLst/>
+          </a:prstGeom>
+          <a:noFill/>
+          <a:ln/>
+        </p:spPr>
+        <p:txBody>
+          <a:bodyPr wrap="square" lIns="0" tIns="0" rIns="0" bIns="0" rtlCol="0" anchor="t"/>
+          <a:lstStyle/>
+          <a:p>
+            <a:pPr indent="0" marL="0">
+              <a:buNone/>
+            </a:pPr>
+            <a:r>
+              <a:rPr lang="en-US" sz="1400" dirty="0">
+                <a:solidFill>
+                  <a:srgbClr val="8B98A8"/>
                 </a:solidFill>
                 <a:latin typeface="Arial" pitchFamily="34" charset="0"/>
                 <a:ea typeface="Arial" pitchFamily="34" charset="-122"/>
                 <a:cs typeface="Arial" pitchFamily="34" charset="-120"/>
               </a:rPr>
-              <a:t>For whoever runs it</a:t>
-            </a:r>
+              <a:t>the CLI and both agents</a:t>
+            </a:r>
+            <a:endParaRPr lang="en-US" sz="1400" dirty="0"/>
+          </a:p>
+        </p:txBody>
+      </p:sp>
+      <p:sp>
+        <p:nvSpPr>
+          <p:cNvPr id="14" name="Text 12"/>
+          <p:cNvSpPr txBox="1"/>
+          <p:nvPr/>
+        </p:nvSpPr>
+        <p:spPr>
+          <a:xfrm>
+            <a:off x="4368698" y="3977640"/>
+            <a:ext cx="3454298" cy="292608"/>
+          </a:xfrm>
+          <a:prstGeom prst="rect">
+            <a:avLst/>
+          </a:prstGeom>
+          <a:noFill/>
+          <a:ln/>
+        </p:spPr>
+        <p:txBody>
+          <a:bodyPr wrap="square" lIns="0" tIns="0" rIns="0" bIns="0" rtlCol="0" anchor="t"/>
+          <a:lstStyle/>
+          <a:p>
+            <a:pPr indent="0" marL="0">
+              <a:buNone/>
+            </a:pPr>
+            <a:r>
+              <a:rPr lang="en-US" sz="1800" dirty="0">
+                <a:solidFill>
+                  <a:srgbClr val="E8EDF2"/>
+                </a:solidFill>
+                <a:latin typeface="Consolas" pitchFamily="34" charset="0"/>
+                <a:ea typeface="Consolas" pitchFamily="34" charset="-122"/>
+                <a:cs typeface="Consolas" pitchFamily="34" charset="-120"/>
+              </a:rPr>
+              <a:t>#agent-install</a:t>
+            </a:r>
+            <a:endParaRPr lang="en-US" sz="1800" dirty="0"/>
+          </a:p>
+        </p:txBody>
+      </p:sp>
+      <p:sp>
+        <p:nvSpPr>
+          <p:cNvPr id="15" name="Text 13"/>
+          <p:cNvSpPr txBox="1"/>
+          <p:nvPr/>
+        </p:nvSpPr>
+        <p:spPr>
+          <a:xfrm>
+            <a:off x="4368698" y="4288536"/>
+            <a:ext cx="3454298" cy="274320"/>
+          </a:xfrm>
+          <a:prstGeom prst="rect">
+            <a:avLst/>
+          </a:prstGeom>
+          <a:noFill/>
+          <a:ln/>
+        </p:spPr>
+        <p:txBody>
+          <a:bodyPr wrap="square" lIns="0" tIns="0" rIns="0" bIns="0" rtlCol="0" anchor="t"/>
+          <a:lstStyle/>
+          <a:p>
             <a:pPr indent="0" marL="0">
               <a:buNone/>
             </a:pPr>
             <a:r>
               <a:rPr lang="en-US" sz="1400" dirty="0">
                 <a:solidFill>
-                  <a:srgbClr val="C6CCD6"/>
+                  <a:srgbClr val="8B98A8"/>
                 </a:solidFill>
                 <a:latin typeface="Arial" pitchFamily="34" charset="0"/>
                 <a:ea typeface="Arial" pitchFamily="34" charset="-122"/>
                 <a:cs typeface="Arial" pitchFamily="34" charset="-120"/>
               </a:rPr>
-              <a:t> - the same beats as a running order, who drives each, and the clock.</a:t>
+              <a:t>the one prompt</a:t>
             </a:r>
             <a:endParaRPr lang="en-US" sz="1400" dirty="0"/>
           </a:p>
@@ -7018,13 +7484,13 @@
       </p:sp>
       <p:sp>
         <p:nvSpPr>
-          <p:cNvPr id="9" name="Text 7"/>
-          <p:cNvSpPr txBox="1"/>
-          <p:nvPr/>
-        </p:nvSpPr>
-        <p:spPr>
-          <a:xfrm>
-            <a:off x="640080" y="3246120"/>
+          <p:cNvPr id="16" name="Text 14"/>
+          <p:cNvSpPr txBox="1"/>
+          <p:nvPr/>
+        </p:nvSpPr>
+        <p:spPr>
+          <a:xfrm>
+            <a:off x="8097317" y="2971800"/>
             <a:ext cx="3454298" cy="237744"/>
           </a:xfrm>
           <a:prstGeom prst="rect">
@@ -7049,7 +7515,7 @@
                 <a:ea typeface="Consolas" pitchFamily="34" charset="-122"/>
                 <a:cs typeface="Consolas" pitchFamily="34" charset="-120"/>
               </a:rPr>
-              <a:t>ROAD 1</a:t>
+              <a:t>ON AIR</a:t>
             </a:r>
             <a:endParaRPr lang="en-US" sz="1100" dirty="0"/>
           </a:p>
@@ -7057,13 +7523,13 @@
       </p:sp>
       <p:sp>
         <p:nvSpPr>
-          <p:cNvPr id="10" name="Text 8"/>
-          <p:cNvSpPr txBox="1"/>
-          <p:nvPr/>
-        </p:nvSpPr>
-        <p:spPr>
-          <a:xfrm>
-            <a:off x="640080" y="3611880"/>
+          <p:cNvPr id="17" name="Text 15"/>
+          <p:cNvSpPr txBox="1"/>
+          <p:nvPr/>
+        </p:nvSpPr>
+        <p:spPr>
+          <a:xfrm>
+            <a:off x="8097317" y="3337560"/>
             <a:ext cx="3454298" cy="292608"/>
           </a:xfrm>
           <a:prstGeom prst="rect">
@@ -7088,7 +7554,7 @@
                 <a:ea typeface="Consolas" pitchFamily="34" charset="-122"/>
                 <a:cs typeface="Consolas" pitchFamily="34" charset="-120"/>
               </a:rPr>
-              <a:t>#first-graphic</a:t>
+              <a:t>#dashboard</a:t>
             </a:r>
             <a:endParaRPr lang="en-US" sz="1800" dirty="0"/>
           </a:p>
@@ -7096,13 +7562,13 @@
       </p:sp>
       <p:sp>
         <p:nvSpPr>
-          <p:cNvPr id="11" name="Text 9"/>
-          <p:cNvSpPr txBox="1"/>
-          <p:nvPr/>
-        </p:nvSpPr>
-        <p:spPr>
-          <a:xfrm>
-            <a:off x="640080" y="3922776"/>
+          <p:cNvPr id="18" name="Text 16"/>
+          <p:cNvSpPr txBox="1"/>
+          <p:nvPr/>
+        </p:nvSpPr>
+        <p:spPr>
+          <a:xfrm>
+            <a:off x="8097317" y="3648456"/>
             <a:ext cx="3454298" cy="274320"/>
           </a:xfrm>
           <a:prstGeom prst="rect">
@@ -7127,7 +7593,7 @@
                 <a:ea typeface="Arial" pitchFamily="34" charset="-122"/>
                 <a:cs typeface="Arial" pitchFamily="34" charset="-120"/>
               </a:rPr>
-              <a:t>the whole road, step by step</a:t>
+              <a:t>production, cues, links</a:t>
             </a:r>
             <a:endParaRPr lang="en-US" sz="1400" dirty="0"/>
           </a:p>
@@ -7135,13 +7601,13 @@
       </p:sp>
       <p:sp>
         <p:nvSpPr>
-          <p:cNvPr id="12" name="Text 10"/>
-          <p:cNvSpPr txBox="1"/>
-          <p:nvPr/>
-        </p:nvSpPr>
-        <p:spPr>
-          <a:xfrm>
-            <a:off x="640080" y="4251960"/>
+          <p:cNvPr id="19" name="Text 17"/>
+          <p:cNvSpPr txBox="1"/>
+          <p:nvPr/>
+        </p:nvSpPr>
+        <p:spPr>
+          <a:xfrm>
+            <a:off x="8097317" y="3977640"/>
             <a:ext cx="3454298" cy="292608"/>
           </a:xfrm>
           <a:prstGeom prst="rect">
@@ -7166,7 +7632,7 @@
                 <a:ea typeface="Consolas" pitchFamily="34" charset="-122"/>
                 <a:cs typeface="Consolas" pitchFamily="34" charset="-120"/>
               </a:rPr>
-              <a:t>#svg</a:t>
+              <a:t>#obs</a:t>
             </a:r>
             <a:endParaRPr lang="en-US" sz="1800" dirty="0"/>
           </a:p>
@@ -7174,13 +7640,13 @@
       </p:sp>
       <p:sp>
         <p:nvSpPr>
-          <p:cNvPr id="13" name="Text 11"/>
-          <p:cNvSpPr txBox="1"/>
-          <p:nvPr/>
-        </p:nvSpPr>
-        <p:spPr>
-          <a:xfrm>
-            <a:off x="640080" y="4562856"/>
+          <p:cNvPr id="20" name="Text 18"/>
+          <p:cNvSpPr txBox="1"/>
+          <p:nvPr/>
+        </p:nvSpPr>
+        <p:spPr>
+          <a:xfrm>
+            <a:off x="8097317" y="4288536"/>
             <a:ext cx="3454298" cy="274320"/>
           </a:xfrm>
           <a:prstGeom prst="rect">
@@ -7205,7 +7671,7 @@
                 <a:ea typeface="Arial" pitchFamily="34" charset="-122"/>
                 <a:cs typeface="Arial" pitchFamily="34" charset="-120"/>
               </a:rPr>
-              <a:t>rules, layers, fonts, export</a:t>
+              <a:t>the browser source</a:t>
             </a:r>
             <a:endParaRPr lang="en-US" sz="1400" dirty="0"/>
           </a:p>
@@ -7213,52 +7679,91 @@
       </p:sp>
       <p:sp>
         <p:nvSpPr>
-          <p:cNvPr id="14" name="Text 12"/>
-          <p:cNvSpPr txBox="1"/>
-          <p:nvPr/>
-        </p:nvSpPr>
-        <p:spPr>
-          <a:xfrm>
-            <a:off x="4368698" y="3246120"/>
-            <a:ext cx="3454298" cy="237744"/>
-          </a:xfrm>
-          <a:prstGeom prst="rect">
-            <a:avLst/>
-          </a:prstGeom>
-          <a:noFill/>
-          <a:ln/>
-        </p:spPr>
-        <p:txBody>
-          <a:bodyPr wrap="square" lIns="0" tIns="0" rIns="0" bIns="0" rtlCol="0" anchor="t"/>
-          <a:lstStyle/>
-          <a:p>
-            <a:pPr indent="0" marL="0">
-              <a:buNone/>
-            </a:pPr>
-            <a:r>
-              <a:rPr lang="en-US" sz="1100" spc="200" kern="0" dirty="0">
-                <a:solidFill>
-                  <a:srgbClr val="F6A623"/>
+          <p:cNvPr id="21" name="Text 19"/>
+          <p:cNvSpPr txBox="1"/>
+          <p:nvPr/>
+        </p:nvSpPr>
+        <p:spPr>
+          <a:xfrm>
+            <a:off x="8097317" y="4617720"/>
+            <a:ext cx="3454298" cy="292608"/>
+          </a:xfrm>
+          <a:prstGeom prst="rect">
+            <a:avLst/>
+          </a:prstGeom>
+          <a:noFill/>
+          <a:ln/>
+        </p:spPr>
+        <p:txBody>
+          <a:bodyPr wrap="square" lIns="0" tIns="0" rIns="0" bIns="0" rtlCol="0" anchor="t"/>
+          <a:lstStyle/>
+          <a:p>
+            <a:pPr indent="0" marL="0">
+              <a:buNone/>
+            </a:pPr>
+            <a:r>
+              <a:rPr lang="en-US" sz="1800" dirty="0">
+                <a:solidFill>
+                  <a:srgbClr val="E8EDF2"/>
                 </a:solidFill>
                 <a:latin typeface="Consolas" pitchFamily="34" charset="0"/>
                 <a:ea typeface="Consolas" pitchFamily="34" charset="-122"/>
                 <a:cs typeface="Consolas" pitchFamily="34" charset="-120"/>
               </a:rPr>
-              <a:t>ROAD 2</a:t>
-            </a:r>
-            <a:endParaRPr lang="en-US" sz="1100" dirty="0"/>
-          </a:p>
-        </p:txBody>
-      </p:sp>
-      <p:sp>
-        <p:nvSpPr>
-          <p:cNvPr id="15" name="Text 13"/>
-          <p:cNvSpPr txBox="1"/>
-          <p:nvPr/>
-        </p:nvSpPr>
-        <p:spPr>
-          <a:xfrm>
-            <a:off x="4368698" y="3611880"/>
+              <a:t>#casparcg</a:t>
+            </a:r>
+            <a:endParaRPr lang="en-US" sz="1800" dirty="0"/>
+          </a:p>
+        </p:txBody>
+      </p:sp>
+      <p:sp>
+        <p:nvSpPr>
+          <p:cNvPr id="22" name="Text 20"/>
+          <p:cNvSpPr txBox="1"/>
+          <p:nvPr/>
+        </p:nvSpPr>
+        <p:spPr>
+          <a:xfrm>
+            <a:off x="8097317" y="4928616"/>
+            <a:ext cx="3454298" cy="274320"/>
+          </a:xfrm>
+          <a:prstGeom prst="rect">
+            <a:avLst/>
+          </a:prstGeom>
+          <a:noFill/>
+          <a:ln/>
+        </p:spPr>
+        <p:txBody>
+          <a:bodyPr wrap="square" lIns="0" tIns="0" rIns="0" bIns="0" rtlCol="0" anchor="t"/>
+          <a:lstStyle/>
+          <a:p>
+            <a:pPr indent="0" marL="0">
+              <a:buNone/>
+            </a:pPr>
+            <a:r>
+              <a:rPr lang="en-US" sz="1400" dirty="0">
+                <a:solidFill>
+                  <a:srgbClr val="8B98A8"/>
+                </a:solidFill>
+                <a:latin typeface="Arial" pitchFamily="34" charset="0"/>
+                <a:ea typeface="Arial" pitchFamily="34" charset="-122"/>
+                <a:cs typeface="Arial" pitchFamily="34" charset="-120"/>
+              </a:rPr>
+              <a:t>URL, file, versions</a:t>
+            </a:r>
+            <a:endParaRPr lang="en-US" sz="1400" dirty="0"/>
+          </a:p>
+        </p:txBody>
+      </p:sp>
+      <p:sp>
+        <p:nvSpPr>
+          <p:cNvPr id="23" name="Text 21"/>
+          <p:cNvSpPr txBox="1"/>
+          <p:nvPr/>
+        </p:nvSpPr>
+        <p:spPr>
+          <a:xfrm>
+            <a:off x="8097317" y="5257800"/>
             <a:ext cx="3454298" cy="292608"/>
           </a:xfrm>
           <a:prstGeom prst="rect">
@@ -7283,7 +7788,7 @@
                 <a:ea typeface="Consolas" pitchFamily="34" charset="-122"/>
                 <a:cs typeface="Consolas" pitchFamily="34" charset="-120"/>
               </a:rPr>
-              <a:t>#claude-code</a:t>
+              <a:t>#export</a:t>
             </a:r>
             <a:endParaRPr lang="en-US" sz="1800" dirty="0"/>
           </a:p>
@@ -7291,13 +7796,13 @@
       </p:sp>
       <p:sp>
         <p:nvSpPr>
-          <p:cNvPr id="16" name="Text 14"/>
-          <p:cNvSpPr txBox="1"/>
-          <p:nvPr/>
-        </p:nvSpPr>
-        <p:spPr>
-          <a:xfrm>
-            <a:off x="4368698" y="3922776"/>
+          <p:cNvPr id="24" name="Text 22"/>
+          <p:cNvSpPr txBox="1"/>
+          <p:nvPr/>
+        </p:nvSpPr>
+        <p:spPr>
+          <a:xfrm>
+            <a:off x="8097317" y="5568696"/>
             <a:ext cx="3454298" cy="274320"/>
           </a:xfrm>
           <a:prstGeom prst="rect">
@@ -7322,7 +7827,7 @@
                 <a:ea typeface="Arial" pitchFamily="34" charset="-122"/>
                 <a:cs typeface="Arial" pitchFamily="34" charset="-120"/>
               </a:rPr>
-              <a:t>the CLI and both agents</a:t>
+              <a:t>every package</a:t>
             </a:r>
             <a:endParaRPr lang="en-US" sz="1400" dirty="0"/>
           </a:p>
@@ -7330,436 +7835,7 @@
       </p:sp>
       <p:sp>
         <p:nvSpPr>
-          <p:cNvPr id="17" name="Text 15"/>
-          <p:cNvSpPr txBox="1"/>
-          <p:nvPr/>
-        </p:nvSpPr>
-        <p:spPr>
-          <a:xfrm>
-            <a:off x="4368698" y="4251960"/>
-            <a:ext cx="3454298" cy="292608"/>
-          </a:xfrm>
-          <a:prstGeom prst="rect">
-            <a:avLst/>
-          </a:prstGeom>
-          <a:noFill/>
-          <a:ln/>
-        </p:spPr>
-        <p:txBody>
-          <a:bodyPr wrap="square" lIns="0" tIns="0" rIns="0" bIns="0" rtlCol="0" anchor="t"/>
-          <a:lstStyle/>
-          <a:p>
-            <a:pPr indent="0" marL="0">
-              <a:buNone/>
-            </a:pPr>
-            <a:r>
-              <a:rPr lang="en-US" sz="1800" dirty="0">
-                <a:solidFill>
-                  <a:srgbClr val="E8EDF2"/>
-                </a:solidFill>
-                <a:latin typeface="Consolas" pitchFamily="34" charset="0"/>
-                <a:ea typeface="Consolas" pitchFamily="34" charset="-122"/>
-                <a:cs typeface="Consolas" pitchFamily="34" charset="-120"/>
-              </a:rPr>
-              <a:t>#agent-install</a:t>
-            </a:r>
-            <a:endParaRPr lang="en-US" sz="1800" dirty="0"/>
-          </a:p>
-        </p:txBody>
-      </p:sp>
-      <p:sp>
-        <p:nvSpPr>
-          <p:cNvPr id="18" name="Text 16"/>
-          <p:cNvSpPr txBox="1"/>
-          <p:nvPr/>
-        </p:nvSpPr>
-        <p:spPr>
-          <a:xfrm>
-            <a:off x="4368698" y="4562856"/>
-            <a:ext cx="3454298" cy="274320"/>
-          </a:xfrm>
-          <a:prstGeom prst="rect">
-            <a:avLst/>
-          </a:prstGeom>
-          <a:noFill/>
-          <a:ln/>
-        </p:spPr>
-        <p:txBody>
-          <a:bodyPr wrap="square" lIns="0" tIns="0" rIns="0" bIns="0" rtlCol="0" anchor="t"/>
-          <a:lstStyle/>
-          <a:p>
-            <a:pPr indent="0" marL="0">
-              <a:buNone/>
-            </a:pPr>
-            <a:r>
-              <a:rPr lang="en-US" sz="1400" dirty="0">
-                <a:solidFill>
-                  <a:srgbClr val="8B98A8"/>
-                </a:solidFill>
-                <a:latin typeface="Arial" pitchFamily="34" charset="0"/>
-                <a:ea typeface="Arial" pitchFamily="34" charset="-122"/>
-                <a:cs typeface="Arial" pitchFamily="34" charset="-120"/>
-              </a:rPr>
-              <a:t>the one prompt</a:t>
-            </a:r>
-            <a:endParaRPr lang="en-US" sz="1400" dirty="0"/>
-          </a:p>
-        </p:txBody>
-      </p:sp>
-      <p:sp>
-        <p:nvSpPr>
-          <p:cNvPr id="19" name="Text 17"/>
-          <p:cNvSpPr txBox="1"/>
-          <p:nvPr/>
-        </p:nvSpPr>
-        <p:spPr>
-          <a:xfrm>
-            <a:off x="8097317" y="3246120"/>
-            <a:ext cx="3454298" cy="237744"/>
-          </a:xfrm>
-          <a:prstGeom prst="rect">
-            <a:avLst/>
-          </a:prstGeom>
-          <a:noFill/>
-          <a:ln/>
-        </p:spPr>
-        <p:txBody>
-          <a:bodyPr wrap="square" lIns="0" tIns="0" rIns="0" bIns="0" rtlCol="0" anchor="t"/>
-          <a:lstStyle/>
-          <a:p>
-            <a:pPr indent="0" marL="0">
-              <a:buNone/>
-            </a:pPr>
-            <a:r>
-              <a:rPr lang="en-US" sz="1100" spc="200" kern="0" dirty="0">
-                <a:solidFill>
-                  <a:srgbClr val="F6A623"/>
-                </a:solidFill>
-                <a:latin typeface="Consolas" pitchFamily="34" charset="0"/>
-                <a:ea typeface="Consolas" pitchFamily="34" charset="-122"/>
-                <a:cs typeface="Consolas" pitchFamily="34" charset="-120"/>
-              </a:rPr>
-              <a:t>ON AIR</a:t>
-            </a:r>
-            <a:endParaRPr lang="en-US" sz="1100" dirty="0"/>
-          </a:p>
-        </p:txBody>
-      </p:sp>
-      <p:sp>
-        <p:nvSpPr>
-          <p:cNvPr id="20" name="Text 18"/>
-          <p:cNvSpPr txBox="1"/>
-          <p:nvPr/>
-        </p:nvSpPr>
-        <p:spPr>
-          <a:xfrm>
-            <a:off x="8097317" y="3611880"/>
-            <a:ext cx="3454298" cy="292608"/>
-          </a:xfrm>
-          <a:prstGeom prst="rect">
-            <a:avLst/>
-          </a:prstGeom>
-          <a:noFill/>
-          <a:ln/>
-        </p:spPr>
-        <p:txBody>
-          <a:bodyPr wrap="square" lIns="0" tIns="0" rIns="0" bIns="0" rtlCol="0" anchor="t"/>
-          <a:lstStyle/>
-          <a:p>
-            <a:pPr indent="0" marL="0">
-              <a:buNone/>
-            </a:pPr>
-            <a:r>
-              <a:rPr lang="en-US" sz="1800" dirty="0">
-                <a:solidFill>
-                  <a:srgbClr val="E8EDF2"/>
-                </a:solidFill>
-                <a:latin typeface="Consolas" pitchFamily="34" charset="0"/>
-                <a:ea typeface="Consolas" pitchFamily="34" charset="-122"/>
-                <a:cs typeface="Consolas" pitchFamily="34" charset="-120"/>
-              </a:rPr>
-              <a:t>#dashboard</a:t>
-            </a:r>
-            <a:endParaRPr lang="en-US" sz="1800" dirty="0"/>
-          </a:p>
-        </p:txBody>
-      </p:sp>
-      <p:sp>
-        <p:nvSpPr>
-          <p:cNvPr id="21" name="Text 19"/>
-          <p:cNvSpPr txBox="1"/>
-          <p:nvPr/>
-        </p:nvSpPr>
-        <p:spPr>
-          <a:xfrm>
-            <a:off x="8097317" y="3922776"/>
-            <a:ext cx="3454298" cy="274320"/>
-          </a:xfrm>
-          <a:prstGeom prst="rect">
-            <a:avLst/>
-          </a:prstGeom>
-          <a:noFill/>
-          <a:ln/>
-        </p:spPr>
-        <p:txBody>
-          <a:bodyPr wrap="square" lIns="0" tIns="0" rIns="0" bIns="0" rtlCol="0" anchor="t"/>
-          <a:lstStyle/>
-          <a:p>
-            <a:pPr indent="0" marL="0">
-              <a:buNone/>
-            </a:pPr>
-            <a:r>
-              <a:rPr lang="en-US" sz="1400" dirty="0">
-                <a:solidFill>
-                  <a:srgbClr val="8B98A8"/>
-                </a:solidFill>
-                <a:latin typeface="Arial" pitchFamily="34" charset="0"/>
-                <a:ea typeface="Arial" pitchFamily="34" charset="-122"/>
-                <a:cs typeface="Arial" pitchFamily="34" charset="-120"/>
-              </a:rPr>
-              <a:t>production, cues, links</a:t>
-            </a:r>
-            <a:endParaRPr lang="en-US" sz="1400" dirty="0"/>
-          </a:p>
-        </p:txBody>
-      </p:sp>
-      <p:sp>
-        <p:nvSpPr>
-          <p:cNvPr id="22" name="Text 20"/>
-          <p:cNvSpPr txBox="1"/>
-          <p:nvPr/>
-        </p:nvSpPr>
-        <p:spPr>
-          <a:xfrm>
-            <a:off x="8097317" y="4251960"/>
-            <a:ext cx="3454298" cy="292608"/>
-          </a:xfrm>
-          <a:prstGeom prst="rect">
-            <a:avLst/>
-          </a:prstGeom>
-          <a:noFill/>
-          <a:ln/>
-        </p:spPr>
-        <p:txBody>
-          <a:bodyPr wrap="square" lIns="0" tIns="0" rIns="0" bIns="0" rtlCol="0" anchor="t"/>
-          <a:lstStyle/>
-          <a:p>
-            <a:pPr indent="0" marL="0">
-              <a:buNone/>
-            </a:pPr>
-            <a:r>
-              <a:rPr lang="en-US" sz="1800" dirty="0">
-                <a:solidFill>
-                  <a:srgbClr val="E8EDF2"/>
-                </a:solidFill>
-                <a:latin typeface="Consolas" pitchFamily="34" charset="0"/>
-                <a:ea typeface="Consolas" pitchFamily="34" charset="-122"/>
-                <a:cs typeface="Consolas" pitchFamily="34" charset="-120"/>
-              </a:rPr>
-              <a:t>#obs</a:t>
-            </a:r>
-            <a:endParaRPr lang="en-US" sz="1800" dirty="0"/>
-          </a:p>
-        </p:txBody>
-      </p:sp>
-      <p:sp>
-        <p:nvSpPr>
-          <p:cNvPr id="23" name="Text 21"/>
-          <p:cNvSpPr txBox="1"/>
-          <p:nvPr/>
-        </p:nvSpPr>
-        <p:spPr>
-          <a:xfrm>
-            <a:off x="8097317" y="4562856"/>
-            <a:ext cx="3454298" cy="274320"/>
-          </a:xfrm>
-          <a:prstGeom prst="rect">
-            <a:avLst/>
-          </a:prstGeom>
-          <a:noFill/>
-          <a:ln/>
-        </p:spPr>
-        <p:txBody>
-          <a:bodyPr wrap="square" lIns="0" tIns="0" rIns="0" bIns="0" rtlCol="0" anchor="t"/>
-          <a:lstStyle/>
-          <a:p>
-            <a:pPr indent="0" marL="0">
-              <a:buNone/>
-            </a:pPr>
-            <a:r>
-              <a:rPr lang="en-US" sz="1400" dirty="0">
-                <a:solidFill>
-                  <a:srgbClr val="8B98A8"/>
-                </a:solidFill>
-                <a:latin typeface="Arial" pitchFamily="34" charset="0"/>
-                <a:ea typeface="Arial" pitchFamily="34" charset="-122"/>
-                <a:cs typeface="Arial" pitchFamily="34" charset="-120"/>
-              </a:rPr>
-              <a:t>the browser source</a:t>
-            </a:r>
-            <a:endParaRPr lang="en-US" sz="1400" dirty="0"/>
-          </a:p>
-        </p:txBody>
-      </p:sp>
-      <p:sp>
-        <p:nvSpPr>
-          <p:cNvPr id="24" name="Text 22"/>
-          <p:cNvSpPr txBox="1"/>
-          <p:nvPr/>
-        </p:nvSpPr>
-        <p:spPr>
-          <a:xfrm>
-            <a:off x="8097317" y="4892040"/>
-            <a:ext cx="3454298" cy="292608"/>
-          </a:xfrm>
-          <a:prstGeom prst="rect">
-            <a:avLst/>
-          </a:prstGeom>
-          <a:noFill/>
-          <a:ln/>
-        </p:spPr>
-        <p:txBody>
-          <a:bodyPr wrap="square" lIns="0" tIns="0" rIns="0" bIns="0" rtlCol="0" anchor="t"/>
-          <a:lstStyle/>
-          <a:p>
-            <a:pPr indent="0" marL="0">
-              <a:buNone/>
-            </a:pPr>
-            <a:r>
-              <a:rPr lang="en-US" sz="1800" dirty="0">
-                <a:solidFill>
-                  <a:srgbClr val="E8EDF2"/>
-                </a:solidFill>
-                <a:latin typeface="Consolas" pitchFamily="34" charset="0"/>
-                <a:ea typeface="Consolas" pitchFamily="34" charset="-122"/>
-                <a:cs typeface="Consolas" pitchFamily="34" charset="-120"/>
-              </a:rPr>
-              <a:t>#casparcg</a:t>
-            </a:r>
-            <a:endParaRPr lang="en-US" sz="1800" dirty="0"/>
-          </a:p>
-        </p:txBody>
-      </p:sp>
-      <p:sp>
-        <p:nvSpPr>
           <p:cNvPr id="25" name="Text 23"/>
-          <p:cNvSpPr txBox="1"/>
-          <p:nvPr/>
-        </p:nvSpPr>
-        <p:spPr>
-          <a:xfrm>
-            <a:off x="8097317" y="5202936"/>
-            <a:ext cx="3454298" cy="274320"/>
-          </a:xfrm>
-          <a:prstGeom prst="rect">
-            <a:avLst/>
-          </a:prstGeom>
-          <a:noFill/>
-          <a:ln/>
-        </p:spPr>
-        <p:txBody>
-          <a:bodyPr wrap="square" lIns="0" tIns="0" rIns="0" bIns="0" rtlCol="0" anchor="t"/>
-          <a:lstStyle/>
-          <a:p>
-            <a:pPr indent="0" marL="0">
-              <a:buNone/>
-            </a:pPr>
-            <a:r>
-              <a:rPr lang="en-US" sz="1400" dirty="0">
-                <a:solidFill>
-                  <a:srgbClr val="8B98A8"/>
-                </a:solidFill>
-                <a:latin typeface="Arial" pitchFamily="34" charset="0"/>
-                <a:ea typeface="Arial" pitchFamily="34" charset="-122"/>
-                <a:cs typeface="Arial" pitchFamily="34" charset="-120"/>
-              </a:rPr>
-              <a:t>URL, file, versions</a:t>
-            </a:r>
-            <a:endParaRPr lang="en-US" sz="1400" dirty="0"/>
-          </a:p>
-        </p:txBody>
-      </p:sp>
-      <p:sp>
-        <p:nvSpPr>
-          <p:cNvPr id="26" name="Text 24"/>
-          <p:cNvSpPr txBox="1"/>
-          <p:nvPr/>
-        </p:nvSpPr>
-        <p:spPr>
-          <a:xfrm>
-            <a:off x="8097317" y="5532120"/>
-            <a:ext cx="3454298" cy="292608"/>
-          </a:xfrm>
-          <a:prstGeom prst="rect">
-            <a:avLst/>
-          </a:prstGeom>
-          <a:noFill/>
-          <a:ln/>
-        </p:spPr>
-        <p:txBody>
-          <a:bodyPr wrap="square" lIns="0" tIns="0" rIns="0" bIns="0" rtlCol="0" anchor="t"/>
-          <a:lstStyle/>
-          <a:p>
-            <a:pPr indent="0" marL="0">
-              <a:buNone/>
-            </a:pPr>
-            <a:r>
-              <a:rPr lang="en-US" sz="1800" dirty="0">
-                <a:solidFill>
-                  <a:srgbClr val="E8EDF2"/>
-                </a:solidFill>
-                <a:latin typeface="Consolas" pitchFamily="34" charset="0"/>
-                <a:ea typeface="Consolas" pitchFamily="34" charset="-122"/>
-                <a:cs typeface="Consolas" pitchFamily="34" charset="-120"/>
-              </a:rPr>
-              <a:t>#export</a:t>
-            </a:r>
-            <a:endParaRPr lang="en-US" sz="1800" dirty="0"/>
-          </a:p>
-        </p:txBody>
-      </p:sp>
-      <p:sp>
-        <p:nvSpPr>
-          <p:cNvPr id="27" name="Text 25"/>
-          <p:cNvSpPr txBox="1"/>
-          <p:nvPr/>
-        </p:nvSpPr>
-        <p:spPr>
-          <a:xfrm>
-            <a:off x="8097317" y="5843016"/>
-            <a:ext cx="3454298" cy="274320"/>
-          </a:xfrm>
-          <a:prstGeom prst="rect">
-            <a:avLst/>
-          </a:prstGeom>
-          <a:noFill/>
-          <a:ln/>
-        </p:spPr>
-        <p:txBody>
-          <a:bodyPr wrap="square" lIns="0" tIns="0" rIns="0" bIns="0" rtlCol="0" anchor="t"/>
-          <a:lstStyle/>
-          <a:p>
-            <a:pPr indent="0" marL="0">
-              <a:buNone/>
-            </a:pPr>
-            <a:r>
-              <a:rPr lang="en-US" sz="1400" dirty="0">
-                <a:solidFill>
-                  <a:srgbClr val="8B98A8"/>
-                </a:solidFill>
-                <a:latin typeface="Arial" pitchFamily="34" charset="0"/>
-                <a:ea typeface="Arial" pitchFamily="34" charset="-122"/>
-                <a:cs typeface="Arial" pitchFamily="34" charset="-120"/>
-              </a:rPr>
-              <a:t>every package</a:t>
-            </a:r>
-            <a:endParaRPr lang="en-US" sz="1400" dirty="0"/>
-          </a:p>
-        </p:txBody>
-      </p:sp>
-      <p:sp>
-        <p:nvSpPr>
-          <p:cNvPr id="28" name="Text 26"/>
           <p:cNvSpPr txBox="1"/>
           <p:nvPr/>
         </p:nvSpPr>

</xml_diff>

<commit_message>
Correct three deck slides the 2026-09-10 rebuild left stale
The rebuild against the owner's 2026-09-10 calls fixed slides 4, 6 and
7 and left the others as they were, but three of those contradict the
script as it now stands:

- slide 3 fanned the output URL out to OBS, CasparCG and OGraf in the
  accent colour under "the room's systems", although call 4 ends the
  day at the hosted player; the targets are now dim, headed as later;
- slide 5 said `save` prints a link that opens at once and `login`
  just asks one question, and the live save on noacg.studio measured
  both false (gap row 14); the code panel now carries the two
  workarounds, the number text adds the 9.3 s live save, and the notes
  stop citing gap rows that closed on 2026-09-10;
- slide 2's notes said CasparCG Connect had never met real hardware.

The deck was regenerated after moving the landed file aside, so the
generator's refusal to overwrite a hand-edited deck still stands.
</commit_message>
<xml_diff>
--- a/docs/presentation-2026-09-25/NoaCG-2026-09-25.pptx
+++ b/docs/presentation-2026-09-25/NoaCG-2026-09-25.pptx
@@ -601,7 +601,7 @@
             <a:r>
               <a:rPr lang="en-US" dirty="0"/>
               <a:t>O1. Every sentence on this slide has a row in docs/PROMISE_AUDIT.md, cited by its promise text: "Free and open source, AGPL-3.0, no paid edition"; "No lock-in: real HTML/CSS/JS, self-contained packages, runs from a local file with no internet" (WORKS WITH A STATED LIMITATION: the single-file targets and the SPX folder run from a file; an OGraf or LiveOS package is ES modules and needs an http server, which is why the slide says single-file); "Exports to SPX Graphics, CasparCG, OBS and vMix, H2R, LiveOS, OGraf"; "No account to create, edit and export"; "A production ... one persistent output URL" (the free account).
-IF ASKED. CasparCG Connect through the CLI agent has not been run against real hardware; the exported package has (docs/STUDENT_RELEASE_ACCEPTANCE.md §2).
+IF ASKED. The exported package has run on the owner's own CasparCG since 2026-08-05 (docs/STUDENT_RELEASE_ACCEPTANCE.md §2). Since 2026-09-10 the output URL and CasparCG Connect have both aired on a real 2.3.2 and a real 2.5.0, on a screen consumer (§5 A4 and A6). SDI, a Decklink card and pressing Put on air from noacg.studio are still unproven.
 Source: docs/DEMO_2026-09-25.md §2 O1; docs/PROMISE_AUDIT.md.</a:t>
             </a:r>
             <a:endParaRPr lang="en-US" dirty="0"/>
@@ -692,7 +692,8 @@
               <a:rPr lang="en-US" dirty="0"/>
               <a:t>O2. This is the deck the script asked for: one picture plus the beat headings. Say the shape out loud now so the room knows why on-air comes last: an imported SVG and an agent-made graphic both become a library record, both go into a production, and both air through one output URL (§0, call 2).
 ORDER. Road 1 goes first because the whole room can do it with no terminal, no subscription and no account (§0, call 3).
-Source: docs/DEMO_2026-09-25.md §0 calls 2 and 3, §2 O2.</a:t>
+THE RIGHT-HAND COLUMN IS LATER, NOT TODAY. On the day the URL plays on our own hosted player and nowhere else (§0 call 4, owner 2026-09-10). OBS, CasparCG and OGraf are drawn dim because they are where the same URL or package goes in a studio session afterwards. Say that once, here, so nobody spends the session waiting for the box.
+Source: docs/DEMO_2026-09-25.md §0 calls 2, 3 and 4, §2 O2.</a:t>
             </a:r>
             <a:endParaRPr lang="en-US" dirty="0"/>
           </a:p>
@@ -878,9 +879,10 @@
               <a:rPr lang="en-US" dirty="0"/>
               <a:t>§4. R2.1 is for everyone, subscription or not. R2.3: you drive one agent on the screen; the evidence is the 2026-08-22 round, 25 of 25 cells validator-clean and every one airable in your own blind read (benchmarks/agent/rounds/2026-08-22/VERDICT.md).
 THE NUMBER. docs/AGENT_CLI.md, "Time to air, measured": one walk, one machine, 2026-09-09, against a dev server on the branch's own build (not 0.3.0 from npm), from an empty folder. 24.8 s is doctor + types + scaffold + validate + inspect + screenshot + pack. Setup once per machine is another 8.7 s.
-R2.5: THE CLOUD LEG IS UNTIMED. The measurement stopped at the package's own fallback player. The cloud save and the studio's output URL were not walked: save refused against the dev server (the CLI's key store is per origin) and writing into the live library from an unattended session was not done. The script carries that leg as §7 row 8, the live save with a stopwatch on it. Do not say "minutes to air" as a measured claim; the slide's wording is the honest one.
-UNSEEN SINCE 2026-08-23. R2.1 against noacg.studio and R2.4 the live save (§7 row 8), and B5 the install lines on a fresh machine, last executed 2026-08-22 for Claude Code and 2026-08-27 for Codex, with the Codex side of the noacg-mcp split not re-verified (§7 row 6). Both are cheap to close before the day.
-Source: docs/DEMO_2026-09-25.md §4, §7 rows 6, 8; docs/AGENT_CLI.md "Time to air, measured".</a:t>
+R2.5: TWO NUMBERS, AND THE LAST HOP IS UNTIMED. 24.8 s is the seven local verbs, a local build against a dev server on 2026-09-09. 9.3 s is save into the live library, the published 0.3.0 against noacg.studio on 2026-09-10. About thirty-five seconds of tool time from an empty folder to a graphic in your library, said as the two numbers. The hop from the library to a production's output URL has not been timed (§7 row 15). Do not round up to a minute and do not say "minutes to air".
+R2.4, THE TWO DEFECTS THE LIVE SAVE FOUND (§7 row 14). The link save prints lands on Home, not on the graphic; the graphic is in Recent graphics 5 s later, so say "it is in your library" and open it from there. And login stores the key and then hangs instead of exiting: warn the room that the terminal goes quiet after they press Allow, and that Ctrl-C is safe. The two comments in the code panel say both.
+ON THIS LAPTOP, BEFORE THE DAY (§7 row 16). The global @noacg/cli here is 0.2.0 and the MCP server prefers it over npx, so R2.3 would run a year of fixes behind with nothing on screen saying so. One command: npm i -g @noacg/cli@latest.
+Source: docs/DEMO_2026-09-25.md §4 R2.1 to R2.5, §7 rows 14, 15 and 16; docs/AGENT_CLI.md "Time to air, measured".</a:t>
             </a:r>
             <a:endParaRPr lang="en-US" dirty="0"/>
           </a:p>
@@ -2796,7 +2798,7 @@
                 <a:ea typeface="Consolas" pitchFamily="34" charset="-122"/>
                 <a:cs typeface="Consolas" pitchFamily="34" charset="-120"/>
               </a:rPr>
-              <a:t>THE ROOM'S SYSTEMS</a:t>
+              <a:t>YOUR SYSTEMS, LATER</a:t>
             </a:r>
             <a:endParaRPr lang="en-US" sz="1100" dirty="0"/>
           </a:p>
@@ -3379,7 +3381,7 @@
                 <a:ea typeface="Arial" pitchFamily="34" charset="-122"/>
                 <a:cs typeface="Arial" pitchFamily="34" charset="-120"/>
               </a:rPr>
-              <a:t>The output, live.</a:t>
+              <a:t>Plays on our player.</a:t>
             </a:r>
             <a:endParaRPr lang="en-US" sz="1250" dirty="0"/>
           </a:p>
@@ -3530,7 +3532,7 @@
             <a:r>
               <a:rPr lang="en-US" sz="1400" b="1" dirty="0">
                 <a:solidFill>
-                  <a:srgbClr val="E8EDF2"/>
+                  <a:srgbClr val="8B98A8"/>
                 </a:solidFill>
                 <a:latin typeface="Arial" pitchFamily="34" charset="0"/>
                 <a:ea typeface="Arial" pitchFamily="34" charset="-122"/>
@@ -3591,7 +3593,7 @@
             <a:r>
               <a:rPr lang="en-US" sz="1400" b="1" dirty="0">
                 <a:solidFill>
-                  <a:srgbClr val="E8EDF2"/>
+                  <a:srgbClr val="8B98A8"/>
                 </a:solidFill>
                 <a:latin typeface="Arial" pitchFamily="34" charset="0"/>
                 <a:ea typeface="Arial" pitchFamily="34" charset="-122"/>
@@ -3652,7 +3654,7 @@
             <a:r>
               <a:rPr lang="en-US" sz="1400" b="1" dirty="0">
                 <a:solidFill>
-                  <a:srgbClr val="E8EDF2"/>
+                  <a:srgbClr val="8B98A8"/>
                 </a:solidFill>
                 <a:latin typeface="Arial" pitchFamily="34" charset="0"/>
                 <a:ea typeface="Arial" pitchFamily="34" charset="-122"/>
@@ -3681,7 +3683,7 @@
           <a:noFill/>
           <a:ln w="19050">
             <a:solidFill>
-              <a:srgbClr val="F6A623"/>
+              <a:srgbClr val="8B98A8"/>
             </a:solidFill>
             <a:prstDash val="solid"/>
             <a:tailEnd type="triangle"/>
@@ -3705,7 +3707,7 @@
           <a:noFill/>
           <a:ln w="19050">
             <a:solidFill>
-              <a:srgbClr val="F6A623"/>
+              <a:srgbClr val="8B98A8"/>
             </a:solidFill>
             <a:prstDash val="solid"/>
             <a:tailEnd type="triangle"/>
@@ -3729,7 +3731,7 @@
           <a:noFill/>
           <a:ln w="19050">
             <a:solidFill>
-              <a:srgbClr val="F6A623"/>
+              <a:srgbClr val="8B98A8"/>
             </a:solidFill>
             <a:prstDash val="solid"/>
             <a:tailEnd type="triangle"/>
@@ -5252,7 +5254,7 @@
                 <a:ea typeface="Consolas" pitchFamily="34" charset="-122"/>
                 <a:cs typeface="Consolas" pitchFamily="34" charset="-120"/>
               </a:rPr>
-              <a:t># once; a browser asks one question</a:t>
+              <a:t># once; quiet after Allow? Ctrl-C is safe</a:t>
             </a:r>
             <a:pPr indent="0" marL="0">
               <a:lnSpc>
@@ -5295,7 +5297,7 @@
                 <a:ea typeface="Consolas" pitchFamily="34" charset="-122"/>
                 <a:cs typeface="Consolas" pitchFamily="34" charset="-120"/>
               </a:rPr>
-              <a:t># prints a link that opens at once</a:t>
+              <a:t># then open it from Home, Recent graphics</a:t>
             </a:r>
             <a:endParaRPr lang="en-US" sz="1400" dirty="0"/>
           </a:p>
@@ -5393,7 +5395,7 @@
                 <a:ea typeface="Arial" pitchFamily="34" charset="-122"/>
                 <a:cs typeface="Arial" pitchFamily="34" charset="-120"/>
               </a:rPr>
-              <a:t>, measured by hand on 2026-09-09. They all start a browser to reach the studio; validate is 10.7 s of it because it also runs the gate and writes three full-size frames. The rest of the clock is what the agent spends designing, plus the hop to a player. Nobody has put a stopwatch on that last leg end to end yet, so this is the number there is.</a:t>
+              <a:t>, measured by hand on 2026-09-09. They all start a browser to reach the studio; validate is 10.7 s of it. Then save put a graphic in the live library in 9.3 s, on 2026-09-10. The hop from the library to air is still untimed.</a:t>
             </a:r>
             <a:endParaRPr lang="en-US" sz="1450" dirty="0"/>
           </a:p>

</xml_diff>